<commit_message>
Update final deliverables for evaluation rubric
</commit_message>
<xml_diff>
--- a/entrega-final/Presentacion_Proyecto7_Zabbix.pptx
+++ b/entrega-final/Presentacion_Proyecto7_Zabbix.pptx
@@ -17,6 +17,8 @@
     <p:sldId id="265" r:id="rId16"/>
     <p:sldId id="266" r:id="rId17"/>
     <p:sldId id="267" r:id="rId18"/>
+    <p:sldId id="268" r:id="rId19"/>
+    <p:sldId id="269" r:id="rId20"/>
   </p:sldIdLst>
   <p:sldSz cx="12191695" cy="6858000" type="screen4x3"/>
   <p:notesSz cx="6858000" cy="9144000"/>
@@ -3292,7 +3294,7 @@
                   <a:srgbClr val="11323D"/>
                 </a:solidFill>
               </a:rPr>
-              <a:t>Resultados</a:t>
+              <a:t>Pruebas de carga</a:t>
             </a:r>
           </a:p>
         </p:txBody>
@@ -3306,7 +3308,7 @@
         <p:spPr>
           <a:xfrm>
             <a:off x="640080" y="1234440"/>
-            <a:ext cx="4800600" cy="4389120"/>
+            <a:ext cx="10515600" cy="4389120"/>
           </a:xfrm>
           <a:prstGeom prst="rect">
             <a:avLst/>
@@ -3330,7 +3332,7 @@
               </a:defRPr>
             </a:pPr>
             <a:r>
-              <a:t>Contenedores principales saludables.</a:t>
+              <a:t>Artillery genera trafico real contra frontend y API.</a:t>
             </a:r>
           </a:p>
           <a:p>
@@ -3345,7 +3347,7 @@
               </a:defRPr>
             </a:pPr>
             <a:r>
-              <a:t>Cuatro servicios con check de disponibilidad activo.</a:t>
+              <a:t>El backend registra telemetria e incidentes en MariaDB.</a:t>
             </a:r>
           </a:p>
           <a:p>
@@ -3360,38 +3362,14 @@
               </a:defRPr>
             </a:pPr>
             <a:r>
-              <a:t>Alertas generadas y recuperadas durante la prueba.</a:t>
-            </a:r>
-          </a:p>
-        </p:txBody>
-      </p:sp>
-      <p:pic>
-        <p:nvPicPr>
-          <p:cNvPr id="4" name="Picture 3" descr="04_zabbix_problems.png"/>
-          <p:cNvPicPr>
-            <a:picLocks noChangeAspect="1"/>
-          </p:cNvPicPr>
-          <p:nvPr/>
-        </p:nvPicPr>
-        <p:blipFill>
-          <a:blip r:embed="rId2"/>
-          <a:stretch>
-            <a:fillRect/>
-          </a:stretch>
-        </p:blipFill>
-        <p:spPr>
-          <a:xfrm>
-            <a:off x="5806440" y="1051560"/>
-            <a:ext cx="5715000" cy="4069080"/>
-          </a:xfrm>
-          <a:prstGeom prst="rect">
-            <a:avLst/>
-          </a:prstGeom>
-        </p:spPr>
-      </p:pic>
-      <p:sp>
-        <p:nvSpPr>
-          <p:cNvPr id="5" name="TextBox 4"/>
+              <a:t>Zabbix observa /metrics, DB status y web scenario publico.</a:t>
+            </a:r>
+          </a:p>
+        </p:txBody>
+      </p:sp>
+      <p:sp>
+        <p:nvSpPr>
+          <p:cNvPr id="4" name="TextBox 3"/>
           <p:cNvSpPr txBox="1"/>
           <p:nvPr/>
         </p:nvSpPr>
@@ -3478,7 +3456,7 @@
                   <a:srgbClr val="11323D"/>
                 </a:solidFill>
               </a:rPr>
-              <a:t>Conclusiones</a:t>
+              <a:t>Resultados</a:t>
             </a:r>
           </a:p>
         </p:txBody>
@@ -3492,7 +3470,7 @@
         <p:spPr>
           <a:xfrm>
             <a:off x="640080" y="1234440"/>
-            <a:ext cx="10515600" cy="4389120"/>
+            <a:ext cx="4800600" cy="4389120"/>
           </a:xfrm>
           <a:prstGeom prst="rect">
             <a:avLst/>
@@ -3516,7 +3494,7 @@
               </a:defRPr>
             </a:pPr>
             <a:r>
-              <a:t>Zabbix centraliza observabilidad operativa.</a:t>
+              <a:t>Contenedores principales saludables.</a:t>
             </a:r>
           </a:p>
           <a:p>
@@ -3531,7 +3509,7 @@
               </a:defRPr>
             </a:pPr>
             <a:r>
-              <a:t>Docker Compose hace el despliegue reproducible.</a:t>
+              <a:t>Cuatro servicios con check de disponibilidad activo.</a:t>
             </a:r>
           </a:p>
           <a:p>
@@ -3546,14 +3524,53 @@
               </a:defRPr>
             </a:pPr>
             <a:r>
-              <a:t>La solucion cumple los requerimientos del Proyecto 7.</a:t>
-            </a:r>
-          </a:p>
-        </p:txBody>
-      </p:sp>
-      <p:sp>
-        <p:nvSpPr>
-          <p:cNvPr id="4" name="TextBox 3"/>
+              <a:t>Alertas generadas y recuperadas durante la prueba.</a:t>
+            </a:r>
+          </a:p>
+          <a:p>
+            <a:pPr>
+              <a:spcAft>
+                <a:spcPts val="800"/>
+              </a:spcAft>
+              <a:defRPr sz="2000">
+                <a:solidFill>
+                  <a:srgbClr val="232D37"/>
+                </a:solidFill>
+              </a:defRPr>
+            </a:pPr>
+            <a:r>
+              <a:t>Auditoria automatica con 0 fallas esperadas.</a:t>
+            </a:r>
+          </a:p>
+        </p:txBody>
+      </p:sp>
+      <p:pic>
+        <p:nvPicPr>
+          <p:cNvPr id="4" name="Picture 3" descr="04_zabbix_problems.png"/>
+          <p:cNvPicPr>
+            <a:picLocks noChangeAspect="1"/>
+          </p:cNvPicPr>
+          <p:nvPr/>
+        </p:nvPicPr>
+        <p:blipFill>
+          <a:blip r:embed="rId2"/>
+          <a:stretch>
+            <a:fillRect/>
+          </a:stretch>
+        </p:blipFill>
+        <p:spPr>
+          <a:xfrm>
+            <a:off x="5806440" y="1051560"/>
+            <a:ext cx="5715000" cy="4069080"/>
+          </a:xfrm>
+          <a:prstGeom prst="rect">
+            <a:avLst/>
+          </a:prstGeom>
+        </p:spPr>
+      </p:pic>
+      <p:sp>
+        <p:nvSpPr>
+          <p:cNvPr id="5" name="TextBox 4"/>
           <p:cNvSpPr txBox="1"/>
           <p:nvPr/>
         </p:nvSpPr>
@@ -3640,7 +3657,7 @@
                   <a:srgbClr val="11323D"/>
                 </a:solidFill>
               </a:rPr>
-              <a:t>Demo en vivo</a:t>
+              <a:t>Entregables</a:t>
             </a:r>
           </a:p>
         </p:txBody>
@@ -3678,7 +3695,7 @@
               </a:defRPr>
             </a:pPr>
             <a:r>
-              <a:t>Abrir Zabbix: http://localhost:8088</a:t>
+              <a:t>Informe IEEE: entrega-final/Informe_IEEE_Proyecto7_Zabbix.pdf.</a:t>
             </a:r>
           </a:p>
           <a:p>
@@ -3693,7 +3710,7 @@
               </a:defRPr>
             </a:pPr>
             <a:r>
-              <a:t>Abrir MailHog: http://localhost:8025</a:t>
+              <a:t>Diapositivas: entrega-final/Presentacion_Proyecto7_Zabbix.pptx.</a:t>
             </a:r>
           </a:p>
           <a:p>
@@ -3708,7 +3725,7 @@
               </a:defRPr>
             </a:pPr>
             <a:r>
-              <a:t>Ejecutar: .\scripts\test-failure.ps1 -Service web-service -Seconds 90</a:t>
+              <a:t>Repo GitHub con README, Compose, scripts y evidencias.</a:t>
             </a:r>
           </a:p>
         </p:txBody>
@@ -3743,6 +3760,345 @@
                 </a:solidFill>
               </a:rPr>
               <a:t>Proyecto 7 - Zabbix | 12</a:t>
+            </a:r>
+          </a:p>
+        </p:txBody>
+      </p:sp>
+    </p:spTree>
+  </p:cSld>
+  <p:clrMapOvr>
+    <a:masterClrMapping/>
+  </p:clrMapOvr>
+</p:sld>
+</file>
+
+<file path=ppt/slides/slide13.xml><?xml version="1.0" encoding="utf-8"?>
+<p:sld xmlns:a="http://schemas.openxmlformats.org/drawingml/2006/main" xmlns:p="http://schemas.openxmlformats.org/presentationml/2006/main" xmlns:r="http://schemas.openxmlformats.org/officeDocument/2006/relationships">
+  <p:cSld>
+    <p:bg>
+      <p:bgPr>
+        <a:solidFill>
+          <a:srgbClr val="F8FAFC"/>
+        </a:solidFill>
+        <a:effectLst/>
+      </p:bgPr>
+    </p:bg>
+    <p:spTree>
+      <p:nvGrpSpPr>
+        <p:cNvPr id="1" name=""/>
+        <p:cNvGrpSpPr/>
+        <p:nvPr/>
+      </p:nvGrpSpPr>
+      <p:grpSpPr/>
+      <p:sp>
+        <p:nvSpPr>
+          <p:cNvPr id="2" name="TextBox 1"/>
+          <p:cNvSpPr txBox="1"/>
+          <p:nvPr/>
+        </p:nvSpPr>
+        <p:spPr>
+          <a:xfrm>
+            <a:off x="502920" y="384048"/>
+            <a:ext cx="6949440" cy="457200"/>
+          </a:xfrm>
+          <a:prstGeom prst="rect">
+            <a:avLst/>
+          </a:prstGeom>
+          <a:noFill/>
+        </p:spPr>
+        <p:txBody>
+          <a:bodyPr wrap="none" anchor="t">
+            <a:spAutoFit/>
+          </a:bodyPr>
+          <a:lstStyle/>
+          <a:p>
+            <a:pPr algn="l"/>
+            <a:r>
+              <a:rPr sz="2800" b="1">
+                <a:solidFill>
+                  <a:srgbClr val="11323D"/>
+                </a:solidFill>
+              </a:rPr>
+              <a:t>Conclusiones</a:t>
+            </a:r>
+          </a:p>
+        </p:txBody>
+      </p:sp>
+      <p:sp>
+        <p:nvSpPr>
+          <p:cNvPr id="3" name="TextBox 2"/>
+          <p:cNvSpPr txBox="1"/>
+          <p:nvPr/>
+        </p:nvSpPr>
+        <p:spPr>
+          <a:xfrm>
+            <a:off x="640080" y="1234440"/>
+            <a:ext cx="10515600" cy="4389120"/>
+          </a:xfrm>
+          <a:prstGeom prst="rect">
+            <a:avLst/>
+          </a:prstGeom>
+          <a:noFill/>
+        </p:spPr>
+        <p:txBody>
+          <a:bodyPr wrap="none">
+            <a:spAutoFit/>
+          </a:bodyPr>
+          <a:lstStyle/>
+          <a:p>
+            <a:pPr>
+              <a:spcAft>
+                <a:spcPts val="800"/>
+              </a:spcAft>
+              <a:defRPr sz="2000">
+                <a:solidFill>
+                  <a:srgbClr val="232D37"/>
+                </a:solidFill>
+              </a:defRPr>
+            </a:pPr>
+            <a:r>
+              <a:t>Zabbix centraliza observabilidad operativa.</a:t>
+            </a:r>
+          </a:p>
+          <a:p>
+            <a:pPr>
+              <a:spcAft>
+                <a:spcPts val="800"/>
+              </a:spcAft>
+              <a:defRPr sz="2000">
+                <a:solidFill>
+                  <a:srgbClr val="232D37"/>
+                </a:solidFill>
+              </a:defRPr>
+            </a:pPr>
+            <a:r>
+              <a:t>Docker Compose hace el despliegue reproducible.</a:t>
+            </a:r>
+          </a:p>
+          <a:p>
+            <a:pPr>
+              <a:spcAft>
+                <a:spcPts val="800"/>
+              </a:spcAft>
+              <a:defRPr sz="2000">
+                <a:solidFill>
+                  <a:srgbClr val="232D37"/>
+                </a:solidFill>
+              </a:defRPr>
+            </a:pPr>
+            <a:r>
+              <a:t>El portal publico, Artillery y /api/compliance elevan la solucion sobre el minimo.</a:t>
+            </a:r>
+          </a:p>
+        </p:txBody>
+      </p:sp>
+      <p:sp>
+        <p:nvSpPr>
+          <p:cNvPr id="4" name="TextBox 3"/>
+          <p:cNvSpPr txBox="1"/>
+          <p:nvPr/>
+        </p:nvSpPr>
+        <p:spPr>
+          <a:xfrm>
+            <a:off x="411480" y="6510528"/>
+            <a:ext cx="3657600" cy="228600"/>
+          </a:xfrm>
+          <a:prstGeom prst="rect">
+            <a:avLst/>
+          </a:prstGeom>
+          <a:noFill/>
+        </p:spPr>
+        <p:txBody>
+          <a:bodyPr wrap="none" anchor="t">
+            <a:spAutoFit/>
+          </a:bodyPr>
+          <a:lstStyle/>
+          <a:p>
+            <a:pPr algn="l"/>
+            <a:r>
+              <a:rPr sz="800" b="0">
+                <a:solidFill>
+                  <a:srgbClr val="5D6B7A"/>
+                </a:solidFill>
+              </a:rPr>
+              <a:t>Proyecto 7 - Zabbix | 13</a:t>
+            </a:r>
+          </a:p>
+        </p:txBody>
+      </p:sp>
+    </p:spTree>
+  </p:cSld>
+  <p:clrMapOvr>
+    <a:masterClrMapping/>
+  </p:clrMapOvr>
+</p:sld>
+</file>
+
+<file path=ppt/slides/slide14.xml><?xml version="1.0" encoding="utf-8"?>
+<p:sld xmlns:a="http://schemas.openxmlformats.org/drawingml/2006/main" xmlns:p="http://schemas.openxmlformats.org/presentationml/2006/main" xmlns:r="http://schemas.openxmlformats.org/officeDocument/2006/relationships">
+  <p:cSld>
+    <p:bg>
+      <p:bgPr>
+        <a:solidFill>
+          <a:srgbClr val="F8FAFC"/>
+        </a:solidFill>
+        <a:effectLst/>
+      </p:bgPr>
+    </p:bg>
+    <p:spTree>
+      <p:nvGrpSpPr>
+        <p:cNvPr id="1" name=""/>
+        <p:cNvGrpSpPr/>
+        <p:nvPr/>
+      </p:nvGrpSpPr>
+      <p:grpSpPr/>
+      <p:sp>
+        <p:nvSpPr>
+          <p:cNvPr id="2" name="TextBox 1"/>
+          <p:cNvSpPr txBox="1"/>
+          <p:nvPr/>
+        </p:nvSpPr>
+        <p:spPr>
+          <a:xfrm>
+            <a:off x="502920" y="384048"/>
+            <a:ext cx="6949440" cy="457200"/>
+          </a:xfrm>
+          <a:prstGeom prst="rect">
+            <a:avLst/>
+          </a:prstGeom>
+          <a:noFill/>
+        </p:spPr>
+        <p:txBody>
+          <a:bodyPr wrap="none" anchor="t">
+            <a:spAutoFit/>
+          </a:bodyPr>
+          <a:lstStyle/>
+          <a:p>
+            <a:pPr algn="l"/>
+            <a:r>
+              <a:rPr sz="2800" b="1">
+                <a:solidFill>
+                  <a:srgbClr val="11323D"/>
+                </a:solidFill>
+              </a:rPr>
+              <a:t>Demo en vivo</a:t>
+            </a:r>
+          </a:p>
+        </p:txBody>
+      </p:sp>
+      <p:sp>
+        <p:nvSpPr>
+          <p:cNvPr id="3" name="TextBox 2"/>
+          <p:cNvSpPr txBox="1"/>
+          <p:nvPr/>
+        </p:nvSpPr>
+        <p:spPr>
+          <a:xfrm>
+            <a:off x="640080" y="1234440"/>
+            <a:ext cx="10515600" cy="4389120"/>
+          </a:xfrm>
+          <a:prstGeom prst="rect">
+            <a:avLst/>
+          </a:prstGeom>
+          <a:noFill/>
+        </p:spPr>
+        <p:txBody>
+          <a:bodyPr wrap="none">
+            <a:spAutoFit/>
+          </a:bodyPr>
+          <a:lstStyle/>
+          <a:p>
+            <a:pPr>
+              <a:spcAft>
+                <a:spcPts val="800"/>
+              </a:spcAft>
+              <a:defRPr sz="2000">
+                <a:solidFill>
+                  <a:srgbClr val="232D37"/>
+                </a:solidFill>
+              </a:defRPr>
+            </a:pPr>
+            <a:r>
+              <a:t>Abrir web-zabbix.negociocontigo.com.</a:t>
+            </a:r>
+          </a:p>
+          <a:p>
+            <a:pPr>
+              <a:spcAft>
+                <a:spcPts val="800"/>
+              </a:spcAft>
+              <a:defRPr sz="2000">
+                <a:solidFill>
+                  <a:srgbClr val="232D37"/>
+                </a:solidFill>
+              </a:defRPr>
+            </a:pPr>
+            <a:r>
+              <a:t>Ejecutar: artillery run tests/artillery-live-demo.yml.</a:t>
+            </a:r>
+          </a:p>
+          <a:p>
+            <a:pPr>
+              <a:spcAft>
+                <a:spcPts val="800"/>
+              </a:spcAft>
+              <a:defRPr sz="2000">
+                <a:solidFill>
+                  <a:srgbClr val="232D37"/>
+                </a:solidFill>
+              </a:defRPr>
+            </a:pPr>
+            <a:r>
+              <a:t>Simular caida: docker compose -f docker-compose.vps.yml stop web-service.</a:t>
+            </a:r>
+          </a:p>
+          <a:p>
+            <a:pPr>
+              <a:spcAft>
+                <a:spcPts val="800"/>
+              </a:spcAft>
+              <a:defRPr sz="2000">
+                <a:solidFill>
+                  <a:srgbClr val="232D37"/>
+                </a:solidFill>
+              </a:defRPr>
+            </a:pPr>
+            <a:r>
+              <a:t>Cerrar con: bash scripts/audit-project.sh.</a:t>
+            </a:r>
+          </a:p>
+        </p:txBody>
+      </p:sp>
+      <p:sp>
+        <p:nvSpPr>
+          <p:cNvPr id="4" name="TextBox 3"/>
+          <p:cNvSpPr txBox="1"/>
+          <p:nvPr/>
+        </p:nvSpPr>
+        <p:spPr>
+          <a:xfrm>
+            <a:off x="411480" y="6510528"/>
+            <a:ext cx="3657600" cy="228600"/>
+          </a:xfrm>
+          <a:prstGeom prst="rect">
+            <a:avLst/>
+          </a:prstGeom>
+          <a:noFill/>
+        </p:spPr>
+        <p:txBody>
+          <a:bodyPr wrap="none" anchor="t">
+            <a:spAutoFit/>
+          </a:bodyPr>
+          <a:lstStyle/>
+          <a:p>
+            <a:pPr algn="l"/>
+            <a:r>
+              <a:rPr sz="800" b="0">
+                <a:solidFill>
+                  <a:srgbClr val="5D6B7A"/>
+                </a:solidFill>
+              </a:rPr>
+              <a:t>Proyecto 7 - Zabbix | 14</a:t>
             </a:r>
           </a:p>
         </p:txBody>
@@ -4035,6 +4391,21 @@
               <a:t>Validar triggers, dashboards, historicos y alertas por correo.</a:t>
             </a:r>
           </a:p>
+          <a:p>
+            <a:pPr>
+              <a:spcAft>
+                <a:spcPts val="800"/>
+              </a:spcAft>
+              <a:defRPr sz="2000">
+                <a:solidFill>
+                  <a:srgbClr val="232D37"/>
+                </a:solidFill>
+              </a:defRPr>
+            </a:pPr>
+            <a:r>
+              <a:t>Agregar portal HTTPS con backend, graficas, SLO y carga Artillery.</a:t>
+            </a:r>
+          </a:p>
         </p:txBody>
       </p:sp>
       <p:sp>
@@ -4197,6 +4568,21 @@
               <a:t>Red interna proyecto7-monitoring para resolucion por nombre.</a:t>
             </a:r>
           </a:p>
+          <a:p>
+            <a:pPr>
+              <a:spcAft>
+                <a:spcPts val="800"/>
+              </a:spcAft>
+              <a:defRPr sz="2000">
+                <a:solidFill>
+                  <a:srgbClr val="232D37"/>
+                </a:solidFill>
+              </a:defRPr>
+            </a:pPr>
+            <a:r>
+              <a:t>Caddy publica subdominios HTTPS en la VPS.</a:t>
+            </a:r>
+          </a:p>
         </p:txBody>
       </p:sp>
       <p:pic>
@@ -4350,7 +4736,7 @@
               </a:defRPr>
             </a:pPr>
             <a:r>
-              <a:t>web-host: HTTP sobre Nginx.</a:t>
+              <a:t>web-host: portal Node.js HTTP.</a:t>
             </a:r>
           </a:p>
           <a:p>
@@ -4596,7 +4982,7 @@
               </a:defRPr>
             </a:pPr>
             <a:r>
-              <a:t>provision_zabbix.py registra hosts, items y triggers por API.</a:t>
+              <a:t>provision_zabbix.py registra hosts, items, triggers y web scenario por API.</a:t>
             </a:r>
           </a:p>
         </p:txBody>
@@ -4743,7 +5129,7 @@
               </a:defRPr>
             </a:pPr>
             <a:r>
-              <a:t>Los checks de servicio entregan 1 cuando responden.</a:t>
+              <a:t>Centro de graficas muestra CPU, memoria, disco, rutas y carga.</a:t>
             </a:r>
           </a:p>
           <a:p>
@@ -4758,7 +5144,7 @@
               </a:defRPr>
             </a:pPr>
             <a:r>
-              <a:t>Los graficos permiten revisar comportamiento historico.</a:t>
+              <a:t>La matriz de cumplimiento /api/compliance cruza requisitos contra evidencia.</a:t>
             </a:r>
           </a:p>
         </p:txBody>
@@ -5115,7 +5501,7 @@
               </a:defRPr>
             </a:pPr>
             <a:r>
-              <a:t>No se usan cuentas reales ni servidores externos.</a:t>
+              <a:t>El portal mailhog-zabbix tiene login propio.</a:t>
             </a:r>
           </a:p>
           <a:p>
@@ -5130,7 +5516,7 @@
               </a:defRPr>
             </a:pPr>
             <a:r>
-              <a:t>La evidencia valida el flujo completo de notificacion.</a:t>
+              <a:t>Tambien existe canal SMTP real del dominio para escalamiento.</a:t>
             </a:r>
           </a:p>
         </p:txBody>

</xml_diff>

<commit_message>
Polish IEEE report and deliverables
</commit_message>
<xml_diff>
--- a/entrega-final/Presentacion_Proyecto7_Zabbix.pptx
+++ b/entrega-final/Presentacion_Proyecto7_Zabbix.pptx
@@ -3209,8 +3209,8 @@
               </a:rPr>
               <a:t>Juan Camilo Ballesteros Sierra
 Luis Felipe Murillo Matallana
-Juan Sebastian Delgado
-Daniela Castro Quinones</a:t>
+Juan Sebastián Delgado
+Daniela Castro Quiñones</a:t>
             </a:r>
           </a:p>
         </p:txBody>
@@ -3332,7 +3332,7 @@
               </a:defRPr>
             </a:pPr>
             <a:r>
-              <a:t>Artillery genera trafico real contra frontend y API.</a:t>
+              <a:t>Artillery genera tráfico real contra frontend y API.</a:t>
             </a:r>
           </a:p>
           <a:p>
@@ -3347,7 +3347,7 @@
               </a:defRPr>
             </a:pPr>
             <a:r>
-              <a:t>El backend registra telemetria e incidentes en MariaDB.</a:t>
+              <a:t>El backend registra telemetría e incidentes en MariaDB.</a:t>
             </a:r>
           </a:p>
           <a:p>
@@ -3362,7 +3362,7 @@
               </a:defRPr>
             </a:pPr>
             <a:r>
-              <a:t>Zabbix observa /metrics, DB status y web scenario publico.</a:t>
+              <a:t>Zabbix observa /metrics, DB status y web scenario público.</a:t>
             </a:r>
           </a:p>
         </p:txBody>
@@ -3539,7 +3539,7 @@
               </a:defRPr>
             </a:pPr>
             <a:r>
-              <a:t>Auditoria automatica con 0 fallas esperadas.</a:t>
+              <a:t>Auditoría automática con 0 fallas esperadas.</a:t>
             </a:r>
           </a:p>
         </p:txBody>
@@ -3887,7 +3887,7 @@
               </a:defRPr>
             </a:pPr>
             <a:r>
-              <a:t>El portal publico, Artillery y /api/compliance elevan la solucion sobre el minimo.</a:t>
+              <a:t>El portal público, Artillery y /api/compliance elevan la solución sobre el mínimo.</a:t>
             </a:r>
           </a:p>
         </p:txBody>
@@ -4049,7 +4049,7 @@
               </a:defRPr>
             </a:pPr>
             <a:r>
-              <a:t>Simular caida: docker compose -f docker-compose.vps.yml stop web-service.</a:t>
+              <a:t>Simular caída: docker compose -f docker-compose.vps.yml stop web-service.</a:t>
             </a:r>
           </a:p>
           <a:p>
@@ -4211,7 +4211,7 @@
               </a:defRPr>
             </a:pPr>
             <a:r>
-              <a:t>La revision manual tarda y no deja historial.</a:t>
+              <a:t>La revisión manual tarda y no deja historial.</a:t>
             </a:r>
           </a:p>
           <a:p>
@@ -4226,7 +4226,7 @@
               </a:defRPr>
             </a:pPr>
             <a:r>
-              <a:t>Se necesita visibilidad, alertas y evidencia para sustentacion.</a:t>
+              <a:t>Se necesita visibilidad, alertas y evidencia para sustentación.</a:t>
             </a:r>
           </a:p>
         </p:txBody>
@@ -4388,7 +4388,7 @@
               </a:defRPr>
             </a:pPr>
             <a:r>
-              <a:t>Validar triggers, dashboards, historicos y alertas por correo.</a:t>
+              <a:t>Validar triggers, dashboards, históricos y alertas por correo.</a:t>
             </a:r>
           </a:p>
           <a:p>
@@ -4403,7 +4403,7 @@
               </a:defRPr>
             </a:pPr>
             <a:r>
-              <a:t>Agregar portal HTTPS con backend, graficas, SLO y carga Artillery.</a:t>
+              <a:t>Agregar portal HTTPS con backend, gráficas, SLO y carga Artillery.</a:t>
             </a:r>
           </a:p>
         </p:txBody>
@@ -4565,7 +4565,7 @@
               </a:defRPr>
             </a:pPr>
             <a:r>
-              <a:t>Red interna proyecto7-monitoring para resolucion por nombre.</a:t>
+              <a:t>Red interna proyecto7-monitoring para resolución por nombre.</a:t>
             </a:r>
           </a:p>
           <a:p>
@@ -4899,7 +4899,7 @@
                   <a:srgbClr val="11323D"/>
                 </a:solidFill>
               </a:rPr>
-              <a:t>Implementacion</a:t>
+              <a:t>Implementación</a:t>
             </a:r>
           </a:p>
         </p:txBody>
@@ -4967,7 +4967,7 @@
               </a:defRPr>
             </a:pPr>
             <a:r>
-              <a:t>Configuraciones Zabbix se montan como volumen.</a:t>
+              <a:t>Las configuraciones Zabbix se montan como volumen.</a:t>
             </a:r>
           </a:p>
           <a:p>
@@ -5114,7 +5114,7 @@
               </a:defRPr>
             </a:pPr>
             <a:r>
-              <a:t>Latest data muestra disponibilidad y metricas.</a:t>
+              <a:t>Latest data muestra disponibilidad y métricas.</a:t>
             </a:r>
           </a:p>
           <a:p>
@@ -5129,7 +5129,7 @@
               </a:defRPr>
             </a:pPr>
             <a:r>
-              <a:t>Centro de graficas muestra CPU, memoria, disco, rutas y carga.</a:t>
+              <a:t>Centro de gráficas muestra CPU, memoria, disco, rutas y carga.</a:t>
             </a:r>
           </a:p>
           <a:p>
@@ -5262,7 +5262,7 @@
                   <a:srgbClr val="11323D"/>
                 </a:solidFill>
               </a:rPr>
-              <a:t>Prueba de caida</a:t>
+              <a:t>Prueba de caída</a:t>
             </a:r>
           </a:p>
         </p:txBody>
@@ -5300,7 +5300,7 @@
               </a:defRPr>
             </a:pPr>
             <a:r>
-              <a:t>Se detiene web-service durante la demostracion.</a:t>
+              <a:t>Se detiene web-service durante la demostración.</a:t>
             </a:r>
           </a:p>
           <a:p>
@@ -5486,7 +5486,7 @@
               </a:defRPr>
             </a:pPr>
             <a:r>
-              <a:t>MailHog recibe correos de problema y recuperacion.</a:t>
+              <a:t>MailHog recibe correos de problema y recuperación.</a:t>
             </a:r>
           </a:p>
           <a:p>
@@ -5516,7 +5516,7 @@
               </a:defRPr>
             </a:pPr>
             <a:r>
-              <a:t>Tambien existe canal SMTP real del dominio para escalamiento.</a:t>
+              <a:t>También existe canal SMTP real del dominio para escalamiento.</a:t>
             </a:r>
           </a:p>
         </p:txBody>

</xml_diff>

<commit_message>
Expand observability demo and polish deck
</commit_message>
<xml_diff>
--- a/entrega-final/Presentacion_Proyecto7_Zabbix.pptx
+++ b/entrega-final/Presentacion_Proyecto7_Zabbix.pptx
@@ -3322,7 +3322,7 @@
                 </a:solidFill>
                 <a:latin typeface="Aptos"/>
               </a:rPr>
-              <a:t>Una plataforma dockerizada con Zabbix 6.x, alertas, backend real, métricas, SLO y pruebas de carga en vivo.</a:t>
+              <a:t>Zabbix 6.x monitoreando servicios Docker, alertas, backend real, métricas, SLO y pruebas de carga en vivo.</a:t>
             </a:r>
           </a:p>
         </p:txBody>
@@ -4136,7 +4136,7 @@
                 </a:solidFill>
                 <a:latin typeface="Aptos Display"/>
               </a:rPr>
-              <a:t>MailHog evidencia las alertas.</a:t>
+              <a:t>MailHog captura alertas.</a:t>
             </a:r>
           </a:p>
         </p:txBody>
@@ -4747,7 +4747,7 @@
                 </a:solidFill>
                 <a:latin typeface="Aptos Display"/>
               </a:rPr>
-              <a:t>Artillery convierte la demo en una prueba de carga.</a:t>
+              <a:t>Artillery mete presión real a la demo.</a:t>
             </a:r>
           </a:p>
         </p:txBody>
@@ -5279,7 +5279,7 @@
                 </a:solidFill>
                 <a:latin typeface="Aptos"/>
               </a:rPr>
-              <a:t>El backend registra telemetría e incidentes en MariaDB mientras Zabbix observa endpoints públicos, DB status y /metrics.</a:t>
+              <a:t>La app no solo responde: guarda telemetría, registra incidentes y expone métricas para Zabbix.</a:t>
             </a:r>
           </a:p>
         </p:txBody>
@@ -5437,7 +5437,7 @@
                 </a:solidFill>
                 <a:latin typeface="Aptos"/>
               </a:rPr>
-              <a:t>Durante la sustentación suben requests, rutas golpeadas, cargas recientes y SLO en el portal.</a:t>
+              <a:t>Mientras corre Artillery suben requests, rutas golpeadas, cargas recientes y SLO en el portal.</a:t>
             </a:r>
           </a:p>
         </p:txBody>
@@ -5753,7 +5753,7 @@
                 </a:solidFill>
                 <a:latin typeface="Aptos Display"/>
               </a:rPr>
-              <a:t>La evaluación queda cubierta con evidencia y verificación reproducible.</a:t>
+              <a:t>El cierre se defiende con métricas y auditoría.</a:t>
             </a:r>
           </a:p>
         </p:txBody>
@@ -6861,7 +6861,7 @@
                 </a:solidFill>
                 <a:latin typeface="Aptos Display"/>
               </a:rPr>
-              <a:t>El proyecto se entrega como repositorio, informe, deck y demo pública.</a:t>
+              <a:t>Queda repo, informe, deck y demo pública.</a:t>
             </a:r>
           </a:p>
         </p:txBody>
@@ -7844,7 +7844,7 @@
                 </a:solidFill>
                 <a:latin typeface="Aptos Display"/>
               </a:rPr>
-              <a:t>La demo cierra con tráfico, caída, alerta y auditoría.</a:t>
+              <a:t>La demo debe cerrar viendo tráfico, caída y alerta.</a:t>
             </a:r>
           </a:p>
         </p:txBody>
@@ -8495,7 +8495,7 @@
                 </a:solidFill>
                 <a:latin typeface="Aptos"/>
               </a:rPr>
-              <a:t>Cierre: Zabbix detecta, MailHog evidencia, Artillery presiona y la auditoría confirma cumplimiento.</a:t>
+              <a:t>Cierre: Zabbix detecta, MailHog muestra, Artillery presiona y la auditoría confirma.</a:t>
             </a:r>
           </a:p>
         </p:txBody>
@@ -8766,7 +8766,7 @@
                 </a:solidFill>
                 <a:latin typeface="Aptos Display"/>
               </a:rPr>
-              <a:t>Sin observabilidad, la falla se detecta tarde y sin evidencia.</a:t>
+              <a:t>El riesgo real es enterarse tarde de una caída.</a:t>
             </a:r>
           </a:p>
         </p:txBody>
@@ -10093,7 +10093,7 @@
                 </a:solidFill>
                 <a:latin typeface="Aptos Display"/>
               </a:rPr>
-              <a:t>La entrega es una plataforma observable, no una maqueta.</a:t>
+              <a:t>Montamos algo que se puede medir, presionar y recuperar.</a:t>
             </a:r>
           </a:p>
         </p:txBody>
@@ -10637,7 +10637,7 @@
                 </a:solidFill>
                 <a:latin typeface="Aptos"/>
               </a:rPr>
-              <a:t>Zabbix observa una infraestructura real, detecta fallas y permite explicar el comportamiento del sistema bajo carga.</a:t>
+              <a:t>La gracia del proyecto está en mostrar operación: salud, carga, incidentes, alertas y recuperación.</a:t>
             </a:r>
           </a:p>
         </p:txBody>
@@ -10908,7 +10908,7 @@
                 </a:solidFill>
                 <a:latin typeface="Aptos Display"/>
               </a:rPr>
-              <a:t>Compose conecta monitoreo, servicios y HTTPS.</a:t>
+              <a:t>Zabbix observa servicios Docker.</a:t>
             </a:r>
           </a:p>
         </p:txBody>
@@ -13164,7 +13164,7 @@
                 </a:solidFill>
                 <a:latin typeface="Aptos Display"/>
               </a:rPr>
-              <a:t>Cuatro servicios distintos quedan medidos como hosts operativos.</a:t>
+              <a:t>El inventario cubre web, base de datos, DNS y FTP.</a:t>
             </a:r>
           </a:p>
         </p:txBody>
@@ -15086,7 +15086,7 @@
                 </a:solidFill>
                 <a:latin typeface="Aptos Display"/>
               </a:rPr>
-              <a:t>El despliegue se puede reconstruir desde archivos, no desde pasos manuales.</a:t>
+              <a:t>Todo se puede levantar de nuevo desde el repo.</a:t>
             </a:r>
           </a:p>
         </p:txBody>
@@ -16524,7 +16524,7 @@
                 </a:solidFill>
                 <a:latin typeface="Aptos"/>
               </a:rPr>
-              <a:t>La solución queda trazable: archivo -&gt; contenedor -&gt; objeto Zabbix -&gt; evidencia -&gt; auditoría.</a:t>
+              <a:t>Cada cosa que se muestra sale de un archivo, un contenedor, un item de Zabbix o una evidencia.</a:t>
             </a:r>
           </a:p>
         </p:txBody>
@@ -16840,7 +16840,7 @@
                 </a:solidFill>
                 <a:latin typeface="Aptos Display"/>
               </a:rPr>
-              <a:t>El dashboard resume la operación.</a:t>
+              <a:t>El dashboard muestra el pulso del sistema.</a:t>
             </a:r>
           </a:p>
         </p:txBody>
@@ -17640,7 +17640,7 @@
                 </a:solidFill>
                 <a:latin typeface="Aptos Display"/>
               </a:rPr>
-              <a:t>Latest data prueba que Zabbix recibe señales de hosts y servicios.</a:t>
+              <a:t>Latest data separa sano de caído.</a:t>
             </a:r>
           </a:p>
         </p:txBody>
@@ -18454,7 +18454,7 @@
                 </a:solidFill>
                 <a:latin typeface="Aptos Display"/>
               </a:rPr>
-              <a:t>La prueba clave recorre falla, problema, alerta y recuperación.</a:t>
+              <a:t>La caída controlada prueba el flujo completo.</a:t>
             </a:r>
           </a:p>
         </p:txBody>

</xml_diff>

<commit_message>
Expand final deck with report structure
</commit_message>
<xml_diff>
--- a/entrega-final/Presentacion_Proyecto7_Zabbix.pptx
+++ b/entrega-final/Presentacion_Proyecto7_Zabbix.pptx
@@ -19,6 +19,9 @@
     <p:sldId id="267" r:id="rId18"/>
     <p:sldId id="268" r:id="rId19"/>
     <p:sldId id="269" r:id="rId20"/>
+    <p:sldId id="270" r:id="rId21"/>
+    <p:sldId id="271" r:id="rId22"/>
+    <p:sldId id="272" r:id="rId23"/>
   </p:sldIdLst>
   <p:sldSz cx="12191695" cy="6858000" type="screen4x3"/>
   <p:notesSz cx="6858000" cy="9144000"/>
@@ -3925,7 +3928,7 @@
                 </a:solidFill>
                 <a:latin typeface="Aptos"/>
               </a:rPr>
-              <a:t>01/14</a:t>
+              <a:t>01/17</a:t>
             </a:r>
           </a:p>
         </p:txBody>
@@ -4581,7 +4584,7 @@
                 </a:solidFill>
                 <a:latin typeface="Aptos"/>
               </a:rPr>
-              <a:t>10/14</a:t>
+              <a:t>10/17</a:t>
             </a:r>
           </a:p>
         </p:txBody>
@@ -5542,7 +5545,7 @@
                 </a:solidFill>
                 <a:latin typeface="Aptos"/>
               </a:rPr>
-              <a:t>11/14</a:t>
+              <a:t>11/17</a:t>
             </a:r>
           </a:p>
         </p:txBody>
@@ -6695,7 +6698,7 @@
                 </a:solidFill>
                 <a:latin typeface="Aptos"/>
               </a:rPr>
-              <a:t>12/14</a:t>
+              <a:t>12/17</a:t>
             </a:r>
           </a:p>
         </p:txBody>
@@ -7633,7 +7636,7 @@
                 </a:solidFill>
                 <a:latin typeface="Aptos"/>
               </a:rPr>
-              <a:t>13/14</a:t>
+              <a:t>13/17</a:t>
             </a:r>
           </a:p>
         </p:txBody>
@@ -8600,7 +8603,3207 @@
                 </a:solidFill>
                 <a:latin typeface="Aptos"/>
               </a:rPr>
-              <a:t>14/14</a:t>
+              <a:t>14/17</a:t>
+            </a:r>
+          </a:p>
+        </p:txBody>
+      </p:sp>
+    </p:spTree>
+  </p:cSld>
+  <p:clrMapOvr>
+    <a:masterClrMapping/>
+  </p:clrMapOvr>
+</p:sld>
+</file>
+
+<file path=ppt/slides/slide15.xml><?xml version="1.0" encoding="utf-8"?>
+<p:sld xmlns:a="http://schemas.openxmlformats.org/drawingml/2006/main" xmlns:p="http://schemas.openxmlformats.org/presentationml/2006/main" xmlns:r="http://schemas.openxmlformats.org/officeDocument/2006/relationships">
+  <p:cSld>
+    <p:bg>
+      <p:bgPr>
+        <a:solidFill>
+          <a:srgbClr val="F7FAF7"/>
+        </a:solidFill>
+        <a:effectLst/>
+      </p:bgPr>
+    </p:bg>
+    <p:spTree>
+      <p:nvGrpSpPr>
+        <p:cNvPr id="1" name=""/>
+        <p:cNvGrpSpPr/>
+        <p:nvPr/>
+      </p:nvGrpSpPr>
+      <p:grpSpPr/>
+      <p:sp>
+        <p:nvSpPr>
+          <p:cNvPr id="2" name="TextBox 1"/>
+          <p:cNvSpPr txBox="1"/>
+          <p:nvPr/>
+        </p:nvSpPr>
+        <p:spPr>
+          <a:xfrm>
+            <a:off x="502920" y="384048"/>
+            <a:ext cx="384048" cy="201168"/>
+          </a:xfrm>
+          <a:prstGeom prst="rect">
+            <a:avLst/>
+          </a:prstGeom>
+          <a:noFill/>
+        </p:spPr>
+        <p:txBody>
+          <a:bodyPr wrap="square" lIns="0" rIns="0" tIns="0" bIns="0" anchor="t">
+            <a:spAutoFit/>
+          </a:bodyPr>
+          <a:lstStyle/>
+          <a:p>
+            <a:pPr algn="l"/>
+            <a:r>
+              <a:rPr sz="800" b="1">
+                <a:solidFill>
+                  <a:srgbClr val="0A1820"/>
+                </a:solidFill>
+                <a:latin typeface="Aptos"/>
+              </a:rPr>
+              <a:t>15</a:t>
+            </a:r>
+          </a:p>
+        </p:txBody>
+      </p:sp>
+      <p:cxnSp>
+        <p:nvCxnSpPr>
+          <p:cNvPr id="3" name="Connector 2"/>
+          <p:cNvCxnSpPr/>
+          <p:nvPr/>
+        </p:nvCxnSpPr>
+        <p:spPr>
+          <a:xfrm>
+            <a:off x="941832" y="475488"/>
+            <a:ext cx="685800" cy="0"/>
+          </a:xfrm>
+          <a:prstGeom prst="line">
+            <a:avLst/>
+          </a:prstGeom>
+          <a:ln w="13970">
+            <a:solidFill>
+              <a:srgbClr val="0A1820"/>
+            </a:solidFill>
+          </a:ln>
+        </p:spPr>
+        <p:style>
+          <a:lnRef idx="2">
+            <a:schemeClr val="accent1"/>
+          </a:lnRef>
+          <a:fillRef idx="0">
+            <a:schemeClr val="accent1"/>
+          </a:fillRef>
+          <a:effectRef idx="1">
+            <a:schemeClr val="accent1"/>
+          </a:effectRef>
+          <a:fontRef idx="minor">
+            <a:schemeClr val="tx1"/>
+          </a:fontRef>
+        </p:style>
+      </p:cxnSp>
+      <p:sp>
+        <p:nvSpPr>
+          <p:cNvPr id="4" name="TextBox 3"/>
+          <p:cNvSpPr txBox="1"/>
+          <p:nvPr/>
+        </p:nvSpPr>
+        <p:spPr>
+          <a:xfrm>
+            <a:off x="1737360" y="356616"/>
+            <a:ext cx="3108960" cy="274320"/>
+          </a:xfrm>
+          <a:prstGeom prst="rect">
+            <a:avLst/>
+          </a:prstGeom>
+          <a:noFill/>
+        </p:spPr>
+        <p:txBody>
+          <a:bodyPr wrap="square" lIns="0" rIns="0" tIns="0" bIns="0" anchor="t">
+            <a:spAutoFit/>
+          </a:bodyPr>
+          <a:lstStyle/>
+          <a:p>
+            <a:pPr algn="l"/>
+            <a:r>
+              <a:rPr sz="800" b="1">
+                <a:solidFill>
+                  <a:srgbClr val="0A1820"/>
+                </a:solidFill>
+                <a:latin typeface="Aptos"/>
+              </a:rPr>
+              <a:t>ALTERNATIVAS</a:t>
+            </a:r>
+          </a:p>
+        </p:txBody>
+      </p:sp>
+      <p:sp>
+        <p:nvSpPr>
+          <p:cNvPr id="5" name="TextBox 4"/>
+          <p:cNvSpPr txBox="1"/>
+          <p:nvPr/>
+        </p:nvSpPr>
+        <p:spPr>
+          <a:xfrm>
+            <a:off x="502920" y="713232"/>
+            <a:ext cx="7498079" cy="868680"/>
+          </a:xfrm>
+          <a:prstGeom prst="rect">
+            <a:avLst/>
+          </a:prstGeom>
+          <a:noFill/>
+        </p:spPr>
+        <p:txBody>
+          <a:bodyPr wrap="square" lIns="0" rIns="0" tIns="0" bIns="0" anchor="t">
+            <a:spAutoFit/>
+          </a:bodyPr>
+          <a:lstStyle/>
+          <a:p>
+            <a:pPr algn="l"/>
+            <a:r>
+              <a:rPr sz="3000" b="1">
+                <a:solidFill>
+                  <a:srgbClr val="0A1820"/>
+                </a:solidFill>
+                <a:latin typeface="Aptos Display"/>
+              </a:rPr>
+              <a:t>Zabbix se eligió por equilibrio entre control, alertas y despliegue local.</a:t>
+            </a:r>
+          </a:p>
+        </p:txBody>
+      </p:sp>
+      <p:sp>
+        <p:nvSpPr>
+          <p:cNvPr id="6" name="Rounded Rectangle 5"/>
+          <p:cNvSpPr/>
+          <p:nvPr/>
+        </p:nvSpPr>
+        <p:spPr>
+          <a:xfrm>
+            <a:off x="749808" y="1572768"/>
+            <a:ext cx="2148840" cy="658368"/>
+          </a:xfrm>
+          <a:prstGeom prst="roundRect">
+            <a:avLst/>
+          </a:prstGeom>
+          <a:solidFill>
+            <a:srgbClr val="FFFFFF"/>
+          </a:solidFill>
+          <a:ln w="10160">
+            <a:solidFill>
+              <a:srgbClr val="BFCCD6"/>
+            </a:solidFill>
+          </a:ln>
+        </p:spPr>
+        <p:style>
+          <a:lnRef idx="1">
+            <a:schemeClr val="accent1"/>
+          </a:lnRef>
+          <a:fillRef idx="3">
+            <a:schemeClr val="accent1"/>
+          </a:fillRef>
+          <a:effectRef idx="2">
+            <a:schemeClr val="accent1"/>
+          </a:effectRef>
+          <a:fontRef idx="minor">
+            <a:schemeClr val="lt1"/>
+          </a:fontRef>
+        </p:style>
+        <p:txBody>
+          <a:bodyPr rtlCol="0" anchor="ctr"/>
+          <a:lstStyle/>
+          <a:p>
+            <a:pPr algn="ctr"/>
+          </a:p>
+        </p:txBody>
+      </p:sp>
+      <p:sp>
+        <p:nvSpPr>
+          <p:cNvPr id="7" name="TextBox 6"/>
+          <p:cNvSpPr txBox="1"/>
+          <p:nvPr/>
+        </p:nvSpPr>
+        <p:spPr>
+          <a:xfrm>
+            <a:off x="932688" y="1719072"/>
+            <a:ext cx="1755648" cy="210312"/>
+          </a:xfrm>
+          <a:prstGeom prst="rect">
+            <a:avLst/>
+          </a:prstGeom>
+          <a:noFill/>
+        </p:spPr>
+        <p:txBody>
+          <a:bodyPr wrap="square" lIns="0" rIns="0" tIns="0" bIns="0" anchor="t">
+            <a:spAutoFit/>
+          </a:bodyPr>
+          <a:lstStyle/>
+          <a:p>
+            <a:pPr algn="l"/>
+            <a:r>
+              <a:rPr sz="1200" b="1">
+                <a:solidFill>
+                  <a:srgbClr val="F59E0B"/>
+                </a:solidFill>
+                <a:latin typeface="Aptos"/>
+              </a:rPr>
+              <a:t>Nagios Core</a:t>
+            </a:r>
+          </a:p>
+        </p:txBody>
+      </p:sp>
+      <p:sp>
+        <p:nvSpPr>
+          <p:cNvPr id="8" name="Rounded Rectangle 7"/>
+          <p:cNvSpPr/>
+          <p:nvPr/>
+        </p:nvSpPr>
+        <p:spPr>
+          <a:xfrm>
+            <a:off x="3090672" y="1572768"/>
+            <a:ext cx="3566160" cy="658368"/>
+          </a:xfrm>
+          <a:prstGeom prst="roundRect">
+            <a:avLst/>
+          </a:prstGeom>
+          <a:solidFill>
+            <a:srgbClr val="F5F8FA"/>
+          </a:solidFill>
+          <a:ln w="10160">
+            <a:solidFill>
+              <a:srgbClr val="BFCCD6"/>
+            </a:solidFill>
+          </a:ln>
+        </p:spPr>
+        <p:style>
+          <a:lnRef idx="1">
+            <a:schemeClr val="accent1"/>
+          </a:lnRef>
+          <a:fillRef idx="3">
+            <a:schemeClr val="accent1"/>
+          </a:fillRef>
+          <a:effectRef idx="2">
+            <a:schemeClr val="accent1"/>
+          </a:effectRef>
+          <a:fontRef idx="minor">
+            <a:schemeClr val="lt1"/>
+          </a:fontRef>
+        </p:style>
+        <p:txBody>
+          <a:bodyPr rtlCol="0" anchor="ctr"/>
+          <a:lstStyle/>
+          <a:p>
+            <a:pPr algn="ctr"/>
+          </a:p>
+        </p:txBody>
+      </p:sp>
+      <p:sp>
+        <p:nvSpPr>
+          <p:cNvPr id="9" name="TextBox 8"/>
+          <p:cNvSpPr txBox="1"/>
+          <p:nvPr/>
+        </p:nvSpPr>
+        <p:spPr>
+          <a:xfrm>
+            <a:off x="3273552" y="1700784"/>
+            <a:ext cx="3154680" cy="256032"/>
+          </a:xfrm>
+          <a:prstGeom prst="rect">
+            <a:avLst/>
+          </a:prstGeom>
+          <a:noFill/>
+        </p:spPr>
+        <p:txBody>
+          <a:bodyPr wrap="square" lIns="0" rIns="0" tIns="0" bIns="0" anchor="t">
+            <a:spAutoFit/>
+          </a:bodyPr>
+          <a:lstStyle/>
+          <a:p>
+            <a:pPr algn="l"/>
+            <a:r>
+              <a:rPr sz="1050" b="0">
+                <a:solidFill>
+                  <a:srgbClr val="0A1820"/>
+                </a:solidFill>
+                <a:latin typeface="Aptos"/>
+              </a:rPr>
+              <a:t>Checks maduros y muchos plugins.</a:t>
+            </a:r>
+          </a:p>
+        </p:txBody>
+      </p:sp>
+      <p:sp>
+        <p:nvSpPr>
+          <p:cNvPr id="10" name="Rounded Rectangle 9"/>
+          <p:cNvSpPr/>
+          <p:nvPr/>
+        </p:nvSpPr>
+        <p:spPr>
+          <a:xfrm>
+            <a:off x="6903720" y="1572768"/>
+            <a:ext cx="4160520" cy="658368"/>
+          </a:xfrm>
+          <a:prstGeom prst="roundRect">
+            <a:avLst/>
+          </a:prstGeom>
+          <a:solidFill>
+            <a:srgbClr val="FAF7F4"/>
+          </a:solidFill>
+          <a:ln w="10160">
+            <a:solidFill>
+              <a:srgbClr val="BFCCD6"/>
+            </a:solidFill>
+          </a:ln>
+        </p:spPr>
+        <p:style>
+          <a:lnRef idx="1">
+            <a:schemeClr val="accent1"/>
+          </a:lnRef>
+          <a:fillRef idx="3">
+            <a:schemeClr val="accent1"/>
+          </a:fillRef>
+          <a:effectRef idx="2">
+            <a:schemeClr val="accent1"/>
+          </a:effectRef>
+          <a:fontRef idx="minor">
+            <a:schemeClr val="lt1"/>
+          </a:fontRef>
+        </p:style>
+        <p:txBody>
+          <a:bodyPr rtlCol="0" anchor="ctr"/>
+          <a:lstStyle/>
+          <a:p>
+            <a:pPr algn="ctr"/>
+          </a:p>
+        </p:txBody>
+      </p:sp>
+      <p:sp>
+        <p:nvSpPr>
+          <p:cNvPr id="11" name="TextBox 10"/>
+          <p:cNvSpPr txBox="1"/>
+          <p:nvPr/>
+        </p:nvSpPr>
+        <p:spPr>
+          <a:xfrm>
+            <a:off x="7086600" y="1700784"/>
+            <a:ext cx="3703320" cy="256032"/>
+          </a:xfrm>
+          <a:prstGeom prst="rect">
+            <a:avLst/>
+          </a:prstGeom>
+          <a:noFill/>
+        </p:spPr>
+        <p:txBody>
+          <a:bodyPr wrap="square" lIns="0" rIns="0" tIns="0" bIns="0" anchor="t">
+            <a:spAutoFit/>
+          </a:bodyPr>
+          <a:lstStyle/>
+          <a:p>
+            <a:pPr algn="l"/>
+            <a:r>
+              <a:rPr sz="1050" b="0">
+                <a:solidFill>
+                  <a:srgbClr val="0A1820"/>
+                </a:solidFill>
+                <a:latin typeface="Aptos"/>
+              </a:rPr>
+              <a:t>UI y dashboards limitados; menor automatización moderna.</a:t>
+            </a:r>
+          </a:p>
+        </p:txBody>
+      </p:sp>
+      <p:sp>
+        <p:nvSpPr>
+          <p:cNvPr id="12" name="Rounded Rectangle 11"/>
+          <p:cNvSpPr/>
+          <p:nvPr/>
+        </p:nvSpPr>
+        <p:spPr>
+          <a:xfrm>
+            <a:off x="749808" y="2532888"/>
+            <a:ext cx="2148840" cy="658368"/>
+          </a:xfrm>
+          <a:prstGeom prst="roundRect">
+            <a:avLst/>
+          </a:prstGeom>
+          <a:solidFill>
+            <a:srgbClr val="FFFFFF"/>
+          </a:solidFill>
+          <a:ln w="10160">
+            <a:solidFill>
+              <a:srgbClr val="BFCCD6"/>
+            </a:solidFill>
+          </a:ln>
+        </p:spPr>
+        <p:style>
+          <a:lnRef idx="1">
+            <a:schemeClr val="accent1"/>
+          </a:lnRef>
+          <a:fillRef idx="3">
+            <a:schemeClr val="accent1"/>
+          </a:fillRef>
+          <a:effectRef idx="2">
+            <a:schemeClr val="accent1"/>
+          </a:effectRef>
+          <a:fontRef idx="minor">
+            <a:schemeClr val="lt1"/>
+          </a:fontRef>
+        </p:style>
+        <p:txBody>
+          <a:bodyPr rtlCol="0" anchor="ctr"/>
+          <a:lstStyle/>
+          <a:p>
+            <a:pPr algn="ctr"/>
+          </a:p>
+        </p:txBody>
+      </p:sp>
+      <p:sp>
+        <p:nvSpPr>
+          <p:cNvPr id="13" name="TextBox 12"/>
+          <p:cNvSpPr txBox="1"/>
+          <p:nvPr/>
+        </p:nvSpPr>
+        <p:spPr>
+          <a:xfrm>
+            <a:off x="932688" y="2679192"/>
+            <a:ext cx="1755648" cy="210312"/>
+          </a:xfrm>
+          <a:prstGeom prst="rect">
+            <a:avLst/>
+          </a:prstGeom>
+          <a:noFill/>
+        </p:spPr>
+        <p:txBody>
+          <a:bodyPr wrap="square" lIns="0" rIns="0" tIns="0" bIns="0" anchor="t">
+            <a:spAutoFit/>
+          </a:bodyPr>
+          <a:lstStyle/>
+          <a:p>
+            <a:pPr algn="l"/>
+            <a:r>
+              <a:rPr sz="1200" b="1">
+                <a:solidFill>
+                  <a:srgbClr val="38BDF8"/>
+                </a:solidFill>
+                <a:latin typeface="Aptos"/>
+              </a:rPr>
+              <a:t>Prometheus + Grafana</a:t>
+            </a:r>
+          </a:p>
+        </p:txBody>
+      </p:sp>
+      <p:sp>
+        <p:nvSpPr>
+          <p:cNvPr id="14" name="Rounded Rectangle 13"/>
+          <p:cNvSpPr/>
+          <p:nvPr/>
+        </p:nvSpPr>
+        <p:spPr>
+          <a:xfrm>
+            <a:off x="3090672" y="2532888"/>
+            <a:ext cx="3566160" cy="658368"/>
+          </a:xfrm>
+          <a:prstGeom prst="roundRect">
+            <a:avLst/>
+          </a:prstGeom>
+          <a:solidFill>
+            <a:srgbClr val="F5F8FA"/>
+          </a:solidFill>
+          <a:ln w="10160">
+            <a:solidFill>
+              <a:srgbClr val="BFCCD6"/>
+            </a:solidFill>
+          </a:ln>
+        </p:spPr>
+        <p:style>
+          <a:lnRef idx="1">
+            <a:schemeClr val="accent1"/>
+          </a:lnRef>
+          <a:fillRef idx="3">
+            <a:schemeClr val="accent1"/>
+          </a:fillRef>
+          <a:effectRef idx="2">
+            <a:schemeClr val="accent1"/>
+          </a:effectRef>
+          <a:fontRef idx="minor">
+            <a:schemeClr val="lt1"/>
+          </a:fontRef>
+        </p:style>
+        <p:txBody>
+          <a:bodyPr rtlCol="0" anchor="ctr"/>
+          <a:lstStyle/>
+          <a:p>
+            <a:pPr algn="ctr"/>
+          </a:p>
+        </p:txBody>
+      </p:sp>
+      <p:sp>
+        <p:nvSpPr>
+          <p:cNvPr id="15" name="TextBox 14"/>
+          <p:cNvSpPr txBox="1"/>
+          <p:nvPr/>
+        </p:nvSpPr>
+        <p:spPr>
+          <a:xfrm>
+            <a:off x="3273552" y="2660904"/>
+            <a:ext cx="3154680" cy="256032"/>
+          </a:xfrm>
+          <a:prstGeom prst="rect">
+            <a:avLst/>
+          </a:prstGeom>
+          <a:noFill/>
+        </p:spPr>
+        <p:txBody>
+          <a:bodyPr wrap="square" lIns="0" rIns="0" tIns="0" bIns="0" anchor="t">
+            <a:spAutoFit/>
+          </a:bodyPr>
+          <a:lstStyle/>
+          <a:p>
+            <a:pPr algn="l"/>
+            <a:r>
+              <a:rPr sz="1050" b="0">
+                <a:solidFill>
+                  <a:srgbClr val="0A1820"/>
+                </a:solidFill>
+                <a:latin typeface="Aptos"/>
+              </a:rPr>
+              <a:t>Métricas modernas y visualización fuerte.</a:t>
+            </a:r>
+          </a:p>
+        </p:txBody>
+      </p:sp>
+      <p:sp>
+        <p:nvSpPr>
+          <p:cNvPr id="16" name="Rounded Rectangle 15"/>
+          <p:cNvSpPr/>
+          <p:nvPr/>
+        </p:nvSpPr>
+        <p:spPr>
+          <a:xfrm>
+            <a:off x="6903720" y="2532888"/>
+            <a:ext cx="4160520" cy="658368"/>
+          </a:xfrm>
+          <a:prstGeom prst="roundRect">
+            <a:avLst/>
+          </a:prstGeom>
+          <a:solidFill>
+            <a:srgbClr val="FAF7F4"/>
+          </a:solidFill>
+          <a:ln w="10160">
+            <a:solidFill>
+              <a:srgbClr val="BFCCD6"/>
+            </a:solidFill>
+          </a:ln>
+        </p:spPr>
+        <p:style>
+          <a:lnRef idx="1">
+            <a:schemeClr val="accent1"/>
+          </a:lnRef>
+          <a:fillRef idx="3">
+            <a:schemeClr val="accent1"/>
+          </a:fillRef>
+          <a:effectRef idx="2">
+            <a:schemeClr val="accent1"/>
+          </a:effectRef>
+          <a:fontRef idx="minor">
+            <a:schemeClr val="lt1"/>
+          </a:fontRef>
+        </p:style>
+        <p:txBody>
+          <a:bodyPr rtlCol="0" anchor="ctr"/>
+          <a:lstStyle/>
+          <a:p>
+            <a:pPr algn="ctr"/>
+          </a:p>
+        </p:txBody>
+      </p:sp>
+      <p:sp>
+        <p:nvSpPr>
+          <p:cNvPr id="17" name="TextBox 16"/>
+          <p:cNvSpPr txBox="1"/>
+          <p:nvPr/>
+        </p:nvSpPr>
+        <p:spPr>
+          <a:xfrm>
+            <a:off x="7086600" y="2660904"/>
+            <a:ext cx="3703320" cy="256032"/>
+          </a:xfrm>
+          <a:prstGeom prst="rect">
+            <a:avLst/>
+          </a:prstGeom>
+          <a:noFill/>
+        </p:spPr>
+        <p:txBody>
+          <a:bodyPr wrap="square" lIns="0" rIns="0" tIns="0" bIns="0" anchor="t">
+            <a:spAutoFit/>
+          </a:bodyPr>
+          <a:lstStyle/>
+          <a:p>
+            <a:pPr algn="l"/>
+            <a:r>
+              <a:rPr sz="1050" b="0">
+                <a:solidFill>
+                  <a:srgbClr val="0A1820"/>
+                </a:solidFill>
+                <a:latin typeface="Aptos"/>
+              </a:rPr>
+              <a:t>Requiere Alertmanager, exporters y más integración.</a:t>
+            </a:r>
+          </a:p>
+        </p:txBody>
+      </p:sp>
+      <p:sp>
+        <p:nvSpPr>
+          <p:cNvPr id="18" name="Rounded Rectangle 17"/>
+          <p:cNvSpPr/>
+          <p:nvPr/>
+        </p:nvSpPr>
+        <p:spPr>
+          <a:xfrm>
+            <a:off x="749808" y="3493008"/>
+            <a:ext cx="2148840" cy="658368"/>
+          </a:xfrm>
+          <a:prstGeom prst="roundRect">
+            <a:avLst/>
+          </a:prstGeom>
+          <a:solidFill>
+            <a:srgbClr val="FFFFFF"/>
+          </a:solidFill>
+          <a:ln w="10160">
+            <a:solidFill>
+              <a:srgbClr val="BFCCD6"/>
+            </a:solidFill>
+          </a:ln>
+        </p:spPr>
+        <p:style>
+          <a:lnRef idx="1">
+            <a:schemeClr val="accent1"/>
+          </a:lnRef>
+          <a:fillRef idx="3">
+            <a:schemeClr val="accent1"/>
+          </a:fillRef>
+          <a:effectRef idx="2">
+            <a:schemeClr val="accent1"/>
+          </a:effectRef>
+          <a:fontRef idx="minor">
+            <a:schemeClr val="lt1"/>
+          </a:fontRef>
+        </p:style>
+        <p:txBody>
+          <a:bodyPr rtlCol="0" anchor="ctr"/>
+          <a:lstStyle/>
+          <a:p>
+            <a:pPr algn="ctr"/>
+          </a:p>
+        </p:txBody>
+      </p:sp>
+      <p:sp>
+        <p:nvSpPr>
+          <p:cNvPr id="19" name="TextBox 18"/>
+          <p:cNvSpPr txBox="1"/>
+          <p:nvPr/>
+        </p:nvSpPr>
+        <p:spPr>
+          <a:xfrm>
+            <a:off x="932688" y="3639312"/>
+            <a:ext cx="1755648" cy="210312"/>
+          </a:xfrm>
+          <a:prstGeom prst="rect">
+            <a:avLst/>
+          </a:prstGeom>
+          <a:noFill/>
+        </p:spPr>
+        <p:txBody>
+          <a:bodyPr wrap="square" lIns="0" rIns="0" tIns="0" bIns="0" anchor="t">
+            <a:spAutoFit/>
+          </a:bodyPr>
+          <a:lstStyle/>
+          <a:p>
+            <a:pPr algn="l"/>
+            <a:r>
+              <a:rPr sz="1200" b="1">
+                <a:solidFill>
+                  <a:srgbClr val="EF4444"/>
+                </a:solidFill>
+                <a:latin typeface="Aptos"/>
+              </a:rPr>
+              <a:t>Datadog</a:t>
+            </a:r>
+          </a:p>
+        </p:txBody>
+      </p:sp>
+      <p:sp>
+        <p:nvSpPr>
+          <p:cNvPr id="20" name="Rounded Rectangle 19"/>
+          <p:cNvSpPr/>
+          <p:nvPr/>
+        </p:nvSpPr>
+        <p:spPr>
+          <a:xfrm>
+            <a:off x="3090672" y="3493008"/>
+            <a:ext cx="3566160" cy="658368"/>
+          </a:xfrm>
+          <a:prstGeom prst="roundRect">
+            <a:avLst/>
+          </a:prstGeom>
+          <a:solidFill>
+            <a:srgbClr val="F5F8FA"/>
+          </a:solidFill>
+          <a:ln w="10160">
+            <a:solidFill>
+              <a:srgbClr val="BFCCD6"/>
+            </a:solidFill>
+          </a:ln>
+        </p:spPr>
+        <p:style>
+          <a:lnRef idx="1">
+            <a:schemeClr val="accent1"/>
+          </a:lnRef>
+          <a:fillRef idx="3">
+            <a:schemeClr val="accent1"/>
+          </a:fillRef>
+          <a:effectRef idx="2">
+            <a:schemeClr val="accent1"/>
+          </a:effectRef>
+          <a:fontRef idx="minor">
+            <a:schemeClr val="lt1"/>
+          </a:fontRef>
+        </p:style>
+        <p:txBody>
+          <a:bodyPr rtlCol="0" anchor="ctr"/>
+          <a:lstStyle/>
+          <a:p>
+            <a:pPr algn="ctr"/>
+          </a:p>
+        </p:txBody>
+      </p:sp>
+      <p:sp>
+        <p:nvSpPr>
+          <p:cNvPr id="21" name="TextBox 20"/>
+          <p:cNvSpPr txBox="1"/>
+          <p:nvPr/>
+        </p:nvSpPr>
+        <p:spPr>
+          <a:xfrm>
+            <a:off x="3273552" y="3621024"/>
+            <a:ext cx="3154680" cy="256032"/>
+          </a:xfrm>
+          <a:prstGeom prst="rect">
+            <a:avLst/>
+          </a:prstGeom>
+          <a:noFill/>
+        </p:spPr>
+        <p:txBody>
+          <a:bodyPr wrap="square" lIns="0" rIns="0" tIns="0" bIns="0" anchor="t">
+            <a:spAutoFit/>
+          </a:bodyPr>
+          <a:lstStyle/>
+          <a:p>
+            <a:pPr algn="l"/>
+            <a:r>
+              <a:rPr sz="1050" b="0">
+                <a:solidFill>
+                  <a:srgbClr val="0A1820"/>
+                </a:solidFill>
+                <a:latin typeface="Aptos"/>
+              </a:rPr>
+              <a:t>Suite SaaS completa con APM y logs.</a:t>
+            </a:r>
+          </a:p>
+        </p:txBody>
+      </p:sp>
+      <p:sp>
+        <p:nvSpPr>
+          <p:cNvPr id="22" name="Rounded Rectangle 21"/>
+          <p:cNvSpPr/>
+          <p:nvPr/>
+        </p:nvSpPr>
+        <p:spPr>
+          <a:xfrm>
+            <a:off x="6903720" y="3493008"/>
+            <a:ext cx="4160520" cy="658368"/>
+          </a:xfrm>
+          <a:prstGeom prst="roundRect">
+            <a:avLst/>
+          </a:prstGeom>
+          <a:solidFill>
+            <a:srgbClr val="FAF7F4"/>
+          </a:solidFill>
+          <a:ln w="10160">
+            <a:solidFill>
+              <a:srgbClr val="BFCCD6"/>
+            </a:solidFill>
+          </a:ln>
+        </p:spPr>
+        <p:style>
+          <a:lnRef idx="1">
+            <a:schemeClr val="accent1"/>
+          </a:lnRef>
+          <a:fillRef idx="3">
+            <a:schemeClr val="accent1"/>
+          </a:fillRef>
+          <a:effectRef idx="2">
+            <a:schemeClr val="accent1"/>
+          </a:effectRef>
+          <a:fontRef idx="minor">
+            <a:schemeClr val="lt1"/>
+          </a:fontRef>
+        </p:style>
+        <p:txBody>
+          <a:bodyPr rtlCol="0" anchor="ctr"/>
+          <a:lstStyle/>
+          <a:p>
+            <a:pPr algn="ctr"/>
+          </a:p>
+        </p:txBody>
+      </p:sp>
+      <p:sp>
+        <p:nvSpPr>
+          <p:cNvPr id="23" name="TextBox 22"/>
+          <p:cNvSpPr txBox="1"/>
+          <p:nvPr/>
+        </p:nvSpPr>
+        <p:spPr>
+          <a:xfrm>
+            <a:off x="7086600" y="3621024"/>
+            <a:ext cx="3703320" cy="256032"/>
+          </a:xfrm>
+          <a:prstGeom prst="rect">
+            <a:avLst/>
+          </a:prstGeom>
+          <a:noFill/>
+        </p:spPr>
+        <p:txBody>
+          <a:bodyPr wrap="square" lIns="0" rIns="0" tIns="0" bIns="0" anchor="t">
+            <a:spAutoFit/>
+          </a:bodyPr>
+          <a:lstStyle/>
+          <a:p>
+            <a:pPr algn="l"/>
+            <a:r>
+              <a:rPr sz="1050" b="0">
+                <a:solidFill>
+                  <a:srgbClr val="0A1820"/>
+                </a:solidFill>
+                <a:latin typeface="Aptos"/>
+              </a:rPr>
+              <a:t>Costo, dependencia externa y datos fuera del laboratorio.</a:t>
+            </a:r>
+          </a:p>
+        </p:txBody>
+      </p:sp>
+      <p:sp>
+        <p:nvSpPr>
+          <p:cNvPr id="24" name="Rounded Rectangle 23"/>
+          <p:cNvSpPr/>
+          <p:nvPr/>
+        </p:nvSpPr>
+        <p:spPr>
+          <a:xfrm>
+            <a:off x="749808" y="4453128"/>
+            <a:ext cx="2148840" cy="658368"/>
+          </a:xfrm>
+          <a:prstGeom prst="roundRect">
+            <a:avLst/>
+          </a:prstGeom>
+          <a:solidFill>
+            <a:srgbClr val="FFFFFF"/>
+          </a:solidFill>
+          <a:ln w="10160">
+            <a:solidFill>
+              <a:srgbClr val="BFCCD6"/>
+            </a:solidFill>
+          </a:ln>
+        </p:spPr>
+        <p:style>
+          <a:lnRef idx="1">
+            <a:schemeClr val="accent1"/>
+          </a:lnRef>
+          <a:fillRef idx="3">
+            <a:schemeClr val="accent1"/>
+          </a:fillRef>
+          <a:effectRef idx="2">
+            <a:schemeClr val="accent1"/>
+          </a:effectRef>
+          <a:fontRef idx="minor">
+            <a:schemeClr val="lt1"/>
+          </a:fontRef>
+        </p:style>
+        <p:txBody>
+          <a:bodyPr rtlCol="0" anchor="ctr"/>
+          <a:lstStyle/>
+          <a:p>
+            <a:pPr algn="ctr"/>
+          </a:p>
+        </p:txBody>
+      </p:sp>
+      <p:sp>
+        <p:nvSpPr>
+          <p:cNvPr id="25" name="TextBox 24"/>
+          <p:cNvSpPr txBox="1"/>
+          <p:nvPr/>
+        </p:nvSpPr>
+        <p:spPr>
+          <a:xfrm>
+            <a:off x="932688" y="4599432"/>
+            <a:ext cx="1755648" cy="210312"/>
+          </a:xfrm>
+          <a:prstGeom prst="rect">
+            <a:avLst/>
+          </a:prstGeom>
+          <a:noFill/>
+        </p:spPr>
+        <p:txBody>
+          <a:bodyPr wrap="square" lIns="0" rIns="0" tIns="0" bIns="0" anchor="t">
+            <a:spAutoFit/>
+          </a:bodyPr>
+          <a:lstStyle/>
+          <a:p>
+            <a:pPr algn="l"/>
+            <a:r>
+              <a:rPr sz="1200" b="1">
+                <a:solidFill>
+                  <a:srgbClr val="22C5AA"/>
+                </a:solidFill>
+                <a:latin typeface="Aptos"/>
+              </a:rPr>
+              <a:t>Zabbix 6.x</a:t>
+            </a:r>
+          </a:p>
+        </p:txBody>
+      </p:sp>
+      <p:sp>
+        <p:nvSpPr>
+          <p:cNvPr id="26" name="Rounded Rectangle 25"/>
+          <p:cNvSpPr/>
+          <p:nvPr/>
+        </p:nvSpPr>
+        <p:spPr>
+          <a:xfrm>
+            <a:off x="3090672" y="4453128"/>
+            <a:ext cx="3566160" cy="658368"/>
+          </a:xfrm>
+          <a:prstGeom prst="roundRect">
+            <a:avLst/>
+          </a:prstGeom>
+          <a:solidFill>
+            <a:srgbClr val="F5F8FA"/>
+          </a:solidFill>
+          <a:ln w="10160">
+            <a:solidFill>
+              <a:srgbClr val="BFCCD6"/>
+            </a:solidFill>
+          </a:ln>
+        </p:spPr>
+        <p:style>
+          <a:lnRef idx="1">
+            <a:schemeClr val="accent1"/>
+          </a:lnRef>
+          <a:fillRef idx="3">
+            <a:schemeClr val="accent1"/>
+          </a:fillRef>
+          <a:effectRef idx="2">
+            <a:schemeClr val="accent1"/>
+          </a:effectRef>
+          <a:fontRef idx="minor">
+            <a:schemeClr val="lt1"/>
+          </a:fontRef>
+        </p:style>
+        <p:txBody>
+          <a:bodyPr rtlCol="0" anchor="ctr"/>
+          <a:lstStyle/>
+          <a:p>
+            <a:pPr algn="ctr"/>
+          </a:p>
+        </p:txBody>
+      </p:sp>
+      <p:sp>
+        <p:nvSpPr>
+          <p:cNvPr id="27" name="TextBox 26"/>
+          <p:cNvSpPr txBox="1"/>
+          <p:nvPr/>
+        </p:nvSpPr>
+        <p:spPr>
+          <a:xfrm>
+            <a:off x="3273552" y="4581144"/>
+            <a:ext cx="3154680" cy="256032"/>
+          </a:xfrm>
+          <a:prstGeom prst="rect">
+            <a:avLst/>
+          </a:prstGeom>
+          <a:noFill/>
+        </p:spPr>
+        <p:txBody>
+          <a:bodyPr wrap="square" lIns="0" rIns="0" tIns="0" bIns="0" anchor="t">
+            <a:spAutoFit/>
+          </a:bodyPr>
+          <a:lstStyle/>
+          <a:p>
+            <a:pPr algn="l"/>
+            <a:r>
+              <a:rPr sz="1050" b="0">
+                <a:solidFill>
+                  <a:srgbClr val="0A1820"/>
+                </a:solidFill>
+                <a:latin typeface="Aptos"/>
+              </a:rPr>
+              <a:t>Agentes, API, triggers, dashboards, histórico y correo integrados.</a:t>
+            </a:r>
+          </a:p>
+        </p:txBody>
+      </p:sp>
+      <p:sp>
+        <p:nvSpPr>
+          <p:cNvPr id="28" name="Rounded Rectangle 27"/>
+          <p:cNvSpPr/>
+          <p:nvPr/>
+        </p:nvSpPr>
+        <p:spPr>
+          <a:xfrm>
+            <a:off x="6903720" y="4453128"/>
+            <a:ext cx="4160520" cy="658368"/>
+          </a:xfrm>
+          <a:prstGeom prst="roundRect">
+            <a:avLst/>
+          </a:prstGeom>
+          <a:solidFill>
+            <a:srgbClr val="FAF7F4"/>
+          </a:solidFill>
+          <a:ln w="10160">
+            <a:solidFill>
+              <a:srgbClr val="BFCCD6"/>
+            </a:solidFill>
+          </a:ln>
+        </p:spPr>
+        <p:style>
+          <a:lnRef idx="1">
+            <a:schemeClr val="accent1"/>
+          </a:lnRef>
+          <a:fillRef idx="3">
+            <a:schemeClr val="accent1"/>
+          </a:fillRef>
+          <a:effectRef idx="2">
+            <a:schemeClr val="accent1"/>
+          </a:effectRef>
+          <a:fontRef idx="minor">
+            <a:schemeClr val="lt1"/>
+          </a:fontRef>
+        </p:style>
+        <p:txBody>
+          <a:bodyPr rtlCol="0" anchor="ctr"/>
+          <a:lstStyle/>
+          <a:p>
+            <a:pPr algn="ctr"/>
+          </a:p>
+        </p:txBody>
+      </p:sp>
+      <p:sp>
+        <p:nvSpPr>
+          <p:cNvPr id="29" name="TextBox 28"/>
+          <p:cNvSpPr txBox="1"/>
+          <p:nvPr/>
+        </p:nvSpPr>
+        <p:spPr>
+          <a:xfrm>
+            <a:off x="7086600" y="4581144"/>
+            <a:ext cx="3703320" cy="256032"/>
+          </a:xfrm>
+          <a:prstGeom prst="rect">
+            <a:avLst/>
+          </a:prstGeom>
+          <a:noFill/>
+        </p:spPr>
+        <p:txBody>
+          <a:bodyPr wrap="square" lIns="0" rIns="0" tIns="0" bIns="0" anchor="t">
+            <a:spAutoFit/>
+          </a:bodyPr>
+          <a:lstStyle/>
+          <a:p>
+            <a:pPr algn="l"/>
+            <a:r>
+              <a:rPr sz="1050" b="0">
+                <a:solidFill>
+                  <a:srgbClr val="0A1820"/>
+                </a:solidFill>
+                <a:latin typeface="Aptos"/>
+              </a:rPr>
+              <a:t>Más configuración inicial, pero reproducible con scripts.</a:t>
+            </a:r>
+          </a:p>
+        </p:txBody>
+      </p:sp>
+      <p:sp>
+        <p:nvSpPr>
+          <p:cNvPr id="30" name="Rounded Rectangle 29"/>
+          <p:cNvSpPr/>
+          <p:nvPr/>
+        </p:nvSpPr>
+        <p:spPr>
+          <a:xfrm>
+            <a:off x="777240" y="5513832"/>
+            <a:ext cx="10287000" cy="713232"/>
+          </a:xfrm>
+          <a:prstGeom prst="roundRect">
+            <a:avLst/>
+          </a:prstGeom>
+          <a:solidFill>
+            <a:srgbClr val="FFFFFF"/>
+          </a:solidFill>
+          <a:ln w="10160">
+            <a:solidFill>
+              <a:srgbClr val="BFCCD6"/>
+            </a:solidFill>
+          </a:ln>
+        </p:spPr>
+        <p:style>
+          <a:lnRef idx="1">
+            <a:schemeClr val="accent1"/>
+          </a:lnRef>
+          <a:fillRef idx="3">
+            <a:schemeClr val="accent1"/>
+          </a:fillRef>
+          <a:effectRef idx="2">
+            <a:schemeClr val="accent1"/>
+          </a:effectRef>
+          <a:fontRef idx="minor">
+            <a:schemeClr val="lt1"/>
+          </a:fontRef>
+        </p:style>
+        <p:txBody>
+          <a:bodyPr rtlCol="0" anchor="ctr"/>
+          <a:lstStyle/>
+          <a:p>
+            <a:pPr algn="ctr"/>
+          </a:p>
+        </p:txBody>
+      </p:sp>
+      <p:sp>
+        <p:nvSpPr>
+          <p:cNvPr id="31" name="Rectangle 30"/>
+          <p:cNvSpPr/>
+          <p:nvPr/>
+        </p:nvSpPr>
+        <p:spPr>
+          <a:xfrm>
+            <a:off x="777240" y="5513832"/>
+            <a:ext cx="73152" cy="713232"/>
+          </a:xfrm>
+          <a:prstGeom prst="rect">
+            <a:avLst/>
+          </a:prstGeom>
+          <a:solidFill>
+            <a:srgbClr val="22C5AA"/>
+          </a:solidFill>
+          <a:ln>
+            <a:noFill/>
+          </a:ln>
+        </p:spPr>
+        <p:style>
+          <a:lnRef idx="1">
+            <a:schemeClr val="accent1"/>
+          </a:lnRef>
+          <a:fillRef idx="3">
+            <a:schemeClr val="accent1"/>
+          </a:fillRef>
+          <a:effectRef idx="2">
+            <a:schemeClr val="accent1"/>
+          </a:effectRef>
+          <a:fontRef idx="minor">
+            <a:schemeClr val="lt1"/>
+          </a:fontRef>
+        </p:style>
+        <p:txBody>
+          <a:bodyPr rtlCol="0" anchor="ctr"/>
+          <a:lstStyle/>
+          <a:p>
+            <a:pPr algn="ctr"/>
+          </a:p>
+        </p:txBody>
+      </p:sp>
+      <p:sp>
+        <p:nvSpPr>
+          <p:cNvPr id="32" name="TextBox 31"/>
+          <p:cNvSpPr txBox="1"/>
+          <p:nvPr/>
+        </p:nvSpPr>
+        <p:spPr>
+          <a:xfrm>
+            <a:off x="1005840" y="5660136"/>
+            <a:ext cx="9902952" cy="219456"/>
+          </a:xfrm>
+          <a:prstGeom prst="rect">
+            <a:avLst/>
+          </a:prstGeom>
+          <a:noFill/>
+        </p:spPr>
+        <p:txBody>
+          <a:bodyPr wrap="square" lIns="0" rIns="0" tIns="0" bIns="0" anchor="t">
+            <a:spAutoFit/>
+          </a:bodyPr>
+          <a:lstStyle/>
+          <a:p>
+            <a:pPr algn="l"/>
+            <a:r>
+              <a:rPr sz="1200" b="1">
+                <a:solidFill>
+                  <a:srgbClr val="22C5AA"/>
+                </a:solidFill>
+                <a:latin typeface="Aptos"/>
+              </a:rPr>
+              <a:t>Decisión</a:t>
+            </a:r>
+          </a:p>
+        </p:txBody>
+      </p:sp>
+      <p:sp>
+        <p:nvSpPr>
+          <p:cNvPr id="33" name="TextBox 32"/>
+          <p:cNvSpPr txBox="1"/>
+          <p:nvPr/>
+        </p:nvSpPr>
+        <p:spPr>
+          <a:xfrm>
+            <a:off x="1005840" y="5943600"/>
+            <a:ext cx="9902952" cy="201167"/>
+          </a:xfrm>
+          <a:prstGeom prst="rect">
+            <a:avLst/>
+          </a:prstGeom>
+          <a:noFill/>
+        </p:spPr>
+        <p:txBody>
+          <a:bodyPr wrap="square" lIns="0" rIns="0" tIns="0" bIns="0" anchor="t">
+            <a:spAutoFit/>
+          </a:bodyPr>
+          <a:lstStyle/>
+          <a:p>
+            <a:pPr algn="l"/>
+            <a:r>
+              <a:rPr sz="1100" b="0">
+                <a:solidFill>
+                  <a:srgbClr val="0A1820"/>
+                </a:solidFill>
+                <a:latin typeface="Aptos"/>
+              </a:rPr>
+              <a:t>Zabbix permite cumplir el enunciado sin SaaS pago: monitoreo de hosts, servicios, triggers, dashboards, histórico, alertas y API en Docker Compose.</a:t>
+            </a:r>
+          </a:p>
+        </p:txBody>
+      </p:sp>
+      <p:cxnSp>
+        <p:nvCxnSpPr>
+          <p:cNvPr id="34" name="Connector 33"/>
+          <p:cNvCxnSpPr/>
+          <p:nvPr/>
+        </p:nvCxnSpPr>
+        <p:spPr>
+          <a:xfrm>
+            <a:off x="502920" y="6428232"/>
+            <a:ext cx="11155680" cy="0"/>
+          </a:xfrm>
+          <a:prstGeom prst="line">
+            <a:avLst/>
+          </a:prstGeom>
+          <a:ln w="8890">
+            <a:solidFill>
+              <a:srgbClr val="BFCCD6"/>
+            </a:solidFill>
+          </a:ln>
+        </p:spPr>
+        <p:style>
+          <a:lnRef idx="2">
+            <a:schemeClr val="accent1"/>
+          </a:lnRef>
+          <a:fillRef idx="0">
+            <a:schemeClr val="accent1"/>
+          </a:fillRef>
+          <a:effectRef idx="1">
+            <a:schemeClr val="accent1"/>
+          </a:effectRef>
+          <a:fontRef idx="minor">
+            <a:schemeClr val="tx1"/>
+          </a:fontRef>
+        </p:style>
+      </p:cxnSp>
+      <p:sp>
+        <p:nvSpPr>
+          <p:cNvPr id="35" name="TextBox 34"/>
+          <p:cNvSpPr txBox="1"/>
+          <p:nvPr/>
+        </p:nvSpPr>
+        <p:spPr>
+          <a:xfrm>
+            <a:off x="502920" y="6519672"/>
+            <a:ext cx="4754880" cy="164592"/>
+          </a:xfrm>
+          <a:prstGeom prst="rect">
+            <a:avLst/>
+          </a:prstGeom>
+          <a:noFill/>
+        </p:spPr>
+        <p:txBody>
+          <a:bodyPr wrap="square" lIns="0" rIns="0" tIns="0" bIns="0" anchor="t">
+            <a:spAutoFit/>
+          </a:bodyPr>
+          <a:lstStyle/>
+          <a:p>
+            <a:pPr algn="l"/>
+            <a:r>
+              <a:rPr sz="750" b="0">
+                <a:solidFill>
+                  <a:srgbClr val="5C6975"/>
+                </a:solidFill>
+                <a:latin typeface="Aptos"/>
+              </a:rPr>
+              <a:t>Proyecto 7 - Monitoreo de infraestructura con Zabbix</a:t>
+            </a:r>
+          </a:p>
+        </p:txBody>
+      </p:sp>
+      <p:sp>
+        <p:nvSpPr>
+          <p:cNvPr id="36" name="TextBox 35"/>
+          <p:cNvSpPr txBox="1"/>
+          <p:nvPr/>
+        </p:nvSpPr>
+        <p:spPr>
+          <a:xfrm>
+            <a:off x="10972800" y="6519672"/>
+            <a:ext cx="640080" cy="164592"/>
+          </a:xfrm>
+          <a:prstGeom prst="rect">
+            <a:avLst/>
+          </a:prstGeom>
+          <a:noFill/>
+        </p:spPr>
+        <p:txBody>
+          <a:bodyPr wrap="square" lIns="0" rIns="0" tIns="0" bIns="0" anchor="t">
+            <a:spAutoFit/>
+          </a:bodyPr>
+          <a:lstStyle/>
+          <a:p>
+            <a:pPr algn="r"/>
+            <a:r>
+              <a:rPr sz="750" b="0">
+                <a:solidFill>
+                  <a:srgbClr val="5C6975"/>
+                </a:solidFill>
+                <a:latin typeface="Aptos"/>
+              </a:rPr>
+              <a:t>15/17</a:t>
+            </a:r>
+          </a:p>
+        </p:txBody>
+      </p:sp>
+    </p:spTree>
+  </p:cSld>
+  <p:clrMapOvr>
+    <a:masterClrMapping/>
+  </p:clrMapOvr>
+</p:sld>
+</file>
+
+<file path=ppt/slides/slide16.xml><?xml version="1.0" encoding="utf-8"?>
+<p:sld xmlns:a="http://schemas.openxmlformats.org/drawingml/2006/main" xmlns:p="http://schemas.openxmlformats.org/presentationml/2006/main" xmlns:r="http://schemas.openxmlformats.org/officeDocument/2006/relationships">
+  <p:cSld>
+    <p:bg>
+      <p:bgPr>
+        <a:solidFill>
+          <a:srgbClr val="F2F7F9"/>
+        </a:solidFill>
+        <a:effectLst/>
+      </p:bgPr>
+    </p:bg>
+    <p:spTree>
+      <p:nvGrpSpPr>
+        <p:cNvPr id="1" name=""/>
+        <p:cNvGrpSpPr/>
+        <p:nvPr/>
+      </p:nvGrpSpPr>
+      <p:grpSpPr/>
+      <p:sp>
+        <p:nvSpPr>
+          <p:cNvPr id="2" name="TextBox 1"/>
+          <p:cNvSpPr txBox="1"/>
+          <p:nvPr/>
+        </p:nvSpPr>
+        <p:spPr>
+          <a:xfrm>
+            <a:off x="502920" y="384048"/>
+            <a:ext cx="384048" cy="201168"/>
+          </a:xfrm>
+          <a:prstGeom prst="rect">
+            <a:avLst/>
+          </a:prstGeom>
+          <a:noFill/>
+        </p:spPr>
+        <p:txBody>
+          <a:bodyPr wrap="square" lIns="0" rIns="0" tIns="0" bIns="0" anchor="t">
+            <a:spAutoFit/>
+          </a:bodyPr>
+          <a:lstStyle/>
+          <a:p>
+            <a:pPr algn="l"/>
+            <a:r>
+              <a:rPr sz="800" b="1">
+                <a:solidFill>
+                  <a:srgbClr val="0A1820"/>
+                </a:solidFill>
+                <a:latin typeface="Aptos"/>
+              </a:rPr>
+              <a:t>16</a:t>
+            </a:r>
+          </a:p>
+        </p:txBody>
+      </p:sp>
+      <p:cxnSp>
+        <p:nvCxnSpPr>
+          <p:cNvPr id="3" name="Connector 2"/>
+          <p:cNvCxnSpPr/>
+          <p:nvPr/>
+        </p:nvCxnSpPr>
+        <p:spPr>
+          <a:xfrm>
+            <a:off x="941832" y="475488"/>
+            <a:ext cx="685800" cy="0"/>
+          </a:xfrm>
+          <a:prstGeom prst="line">
+            <a:avLst/>
+          </a:prstGeom>
+          <a:ln w="13970">
+            <a:solidFill>
+              <a:srgbClr val="0A1820"/>
+            </a:solidFill>
+          </a:ln>
+        </p:spPr>
+        <p:style>
+          <a:lnRef idx="2">
+            <a:schemeClr val="accent1"/>
+          </a:lnRef>
+          <a:fillRef idx="0">
+            <a:schemeClr val="accent1"/>
+          </a:fillRef>
+          <a:effectRef idx="1">
+            <a:schemeClr val="accent1"/>
+          </a:effectRef>
+          <a:fontRef idx="minor">
+            <a:schemeClr val="tx1"/>
+          </a:fontRef>
+        </p:style>
+      </p:cxnSp>
+      <p:sp>
+        <p:nvSpPr>
+          <p:cNvPr id="4" name="TextBox 3"/>
+          <p:cNvSpPr txBox="1"/>
+          <p:nvPr/>
+        </p:nvSpPr>
+        <p:spPr>
+          <a:xfrm>
+            <a:off x="1737360" y="356616"/>
+            <a:ext cx="3108960" cy="274320"/>
+          </a:xfrm>
+          <a:prstGeom prst="rect">
+            <a:avLst/>
+          </a:prstGeom>
+          <a:noFill/>
+        </p:spPr>
+        <p:txBody>
+          <a:bodyPr wrap="square" lIns="0" rIns="0" tIns="0" bIns="0" anchor="t">
+            <a:spAutoFit/>
+          </a:bodyPr>
+          <a:lstStyle/>
+          <a:p>
+            <a:pPr algn="l"/>
+            <a:r>
+              <a:rPr sz="800" b="1">
+                <a:solidFill>
+                  <a:srgbClr val="0A1820"/>
+                </a:solidFill>
+                <a:latin typeface="Aptos"/>
+              </a:rPr>
+              <a:t>DISCUSIÓN</a:t>
+            </a:r>
+          </a:p>
+        </p:txBody>
+      </p:sp>
+      <p:sp>
+        <p:nvSpPr>
+          <p:cNvPr id="5" name="TextBox 4"/>
+          <p:cNvSpPr txBox="1"/>
+          <p:nvPr/>
+        </p:nvSpPr>
+        <p:spPr>
+          <a:xfrm>
+            <a:off x="502920" y="713232"/>
+            <a:ext cx="7498079" cy="868680"/>
+          </a:xfrm>
+          <a:prstGeom prst="rect">
+            <a:avLst/>
+          </a:prstGeom>
+          <a:noFill/>
+        </p:spPr>
+        <p:txBody>
+          <a:bodyPr wrap="square" lIns="0" rIns="0" tIns="0" bIns="0" anchor="t">
+            <a:spAutoFit/>
+          </a:bodyPr>
+          <a:lstStyle/>
+          <a:p>
+            <a:pPr algn="l"/>
+            <a:r>
+              <a:rPr sz="3000" b="1">
+                <a:solidFill>
+                  <a:srgbClr val="0A1820"/>
+                </a:solidFill>
+                <a:latin typeface="Aptos Display"/>
+              </a:rPr>
+              <a:t>La prueba importante no es instalar Zabbix; es cerrar el ciclo operativo.</a:t>
+            </a:r>
+          </a:p>
+        </p:txBody>
+      </p:sp>
+      <p:sp>
+        <p:nvSpPr>
+          <p:cNvPr id="6" name="Rounded Rectangle 5"/>
+          <p:cNvSpPr/>
+          <p:nvPr/>
+        </p:nvSpPr>
+        <p:spPr>
+          <a:xfrm>
+            <a:off x="777240" y="1737360"/>
+            <a:ext cx="3246120" cy="1298448"/>
+          </a:xfrm>
+          <a:prstGeom prst="roundRect">
+            <a:avLst/>
+          </a:prstGeom>
+          <a:solidFill>
+            <a:srgbClr val="FFFFFF"/>
+          </a:solidFill>
+          <a:ln w="10160">
+            <a:solidFill>
+              <a:srgbClr val="BFCCD6"/>
+            </a:solidFill>
+          </a:ln>
+        </p:spPr>
+        <p:style>
+          <a:lnRef idx="1">
+            <a:schemeClr val="accent1"/>
+          </a:lnRef>
+          <a:fillRef idx="3">
+            <a:schemeClr val="accent1"/>
+          </a:fillRef>
+          <a:effectRef idx="2">
+            <a:schemeClr val="accent1"/>
+          </a:effectRef>
+          <a:fontRef idx="minor">
+            <a:schemeClr val="lt1"/>
+          </a:fontRef>
+        </p:style>
+        <p:txBody>
+          <a:bodyPr rtlCol="0" anchor="ctr"/>
+          <a:lstStyle/>
+          <a:p>
+            <a:pPr algn="ctr"/>
+          </a:p>
+        </p:txBody>
+      </p:sp>
+      <p:sp>
+        <p:nvSpPr>
+          <p:cNvPr id="7" name="Rectangle 6"/>
+          <p:cNvSpPr/>
+          <p:nvPr/>
+        </p:nvSpPr>
+        <p:spPr>
+          <a:xfrm>
+            <a:off x="777240" y="1737360"/>
+            <a:ext cx="73152" cy="1298448"/>
+          </a:xfrm>
+          <a:prstGeom prst="rect">
+            <a:avLst/>
+          </a:prstGeom>
+          <a:solidFill>
+            <a:srgbClr val="22C5AA"/>
+          </a:solidFill>
+          <a:ln>
+            <a:noFill/>
+          </a:ln>
+        </p:spPr>
+        <p:style>
+          <a:lnRef idx="1">
+            <a:schemeClr val="accent1"/>
+          </a:lnRef>
+          <a:fillRef idx="3">
+            <a:schemeClr val="accent1"/>
+          </a:fillRef>
+          <a:effectRef idx="2">
+            <a:schemeClr val="accent1"/>
+          </a:effectRef>
+          <a:fontRef idx="minor">
+            <a:schemeClr val="lt1"/>
+          </a:fontRef>
+        </p:style>
+        <p:txBody>
+          <a:bodyPr rtlCol="0" anchor="ctr"/>
+          <a:lstStyle/>
+          <a:p>
+            <a:pPr algn="ctr"/>
+          </a:p>
+        </p:txBody>
+      </p:sp>
+      <p:sp>
+        <p:nvSpPr>
+          <p:cNvPr id="8" name="TextBox 7"/>
+          <p:cNvSpPr txBox="1"/>
+          <p:nvPr/>
+        </p:nvSpPr>
+        <p:spPr>
+          <a:xfrm>
+            <a:off x="1005840" y="1883664"/>
+            <a:ext cx="2862072" cy="219456"/>
+          </a:xfrm>
+          <a:prstGeom prst="rect">
+            <a:avLst/>
+          </a:prstGeom>
+          <a:noFill/>
+        </p:spPr>
+        <p:txBody>
+          <a:bodyPr wrap="square" lIns="0" rIns="0" tIns="0" bIns="0" anchor="t">
+            <a:spAutoFit/>
+          </a:bodyPr>
+          <a:lstStyle/>
+          <a:p>
+            <a:pPr algn="l"/>
+            <a:r>
+              <a:rPr sz="1200" b="1">
+                <a:solidFill>
+                  <a:srgbClr val="22C5AA"/>
+                </a:solidFill>
+                <a:latin typeface="Aptos"/>
+              </a:rPr>
+              <a:t>Qué probamos</a:t>
+            </a:r>
+          </a:p>
+        </p:txBody>
+      </p:sp>
+      <p:sp>
+        <p:nvSpPr>
+          <p:cNvPr id="9" name="TextBox 8"/>
+          <p:cNvSpPr txBox="1"/>
+          <p:nvPr/>
+        </p:nvSpPr>
+        <p:spPr>
+          <a:xfrm>
+            <a:off x="1005840" y="2167128"/>
+            <a:ext cx="2862072" cy="786383"/>
+          </a:xfrm>
+          <a:prstGeom prst="rect">
+            <a:avLst/>
+          </a:prstGeom>
+          <a:noFill/>
+        </p:spPr>
+        <p:txBody>
+          <a:bodyPr wrap="square" lIns="0" rIns="0" tIns="0" bIns="0" anchor="t">
+            <a:spAutoFit/>
+          </a:bodyPr>
+          <a:lstStyle/>
+          <a:p>
+            <a:pPr algn="l"/>
+            <a:r>
+              <a:rPr sz="1100" b="0">
+                <a:solidFill>
+                  <a:srgbClr val="0A1820"/>
+                </a:solidFill>
+                <a:latin typeface="Aptos"/>
+              </a:rPr>
+              <a:t>Carga real con Artillery, caída controlada, detección en Zabbix, correo MailHog, recuperación y métricas históricas.</a:t>
+            </a:r>
+          </a:p>
+        </p:txBody>
+      </p:sp>
+      <p:sp>
+        <p:nvSpPr>
+          <p:cNvPr id="10" name="Rounded Rectangle 9"/>
+          <p:cNvSpPr/>
+          <p:nvPr/>
+        </p:nvSpPr>
+        <p:spPr>
+          <a:xfrm>
+            <a:off x="4434840" y="1737360"/>
+            <a:ext cx="3246120" cy="1298448"/>
+          </a:xfrm>
+          <a:prstGeom prst="roundRect">
+            <a:avLst/>
+          </a:prstGeom>
+          <a:solidFill>
+            <a:srgbClr val="FFFFFF"/>
+          </a:solidFill>
+          <a:ln w="10160">
+            <a:solidFill>
+              <a:srgbClr val="BFCCD6"/>
+            </a:solidFill>
+          </a:ln>
+        </p:spPr>
+        <p:style>
+          <a:lnRef idx="1">
+            <a:schemeClr val="accent1"/>
+          </a:lnRef>
+          <a:fillRef idx="3">
+            <a:schemeClr val="accent1"/>
+          </a:fillRef>
+          <a:effectRef idx="2">
+            <a:schemeClr val="accent1"/>
+          </a:effectRef>
+          <a:fontRef idx="minor">
+            <a:schemeClr val="lt1"/>
+          </a:fontRef>
+        </p:style>
+        <p:txBody>
+          <a:bodyPr rtlCol="0" anchor="ctr"/>
+          <a:lstStyle/>
+          <a:p>
+            <a:pPr algn="ctr"/>
+          </a:p>
+        </p:txBody>
+      </p:sp>
+      <p:sp>
+        <p:nvSpPr>
+          <p:cNvPr id="11" name="Rectangle 10"/>
+          <p:cNvSpPr/>
+          <p:nvPr/>
+        </p:nvSpPr>
+        <p:spPr>
+          <a:xfrm>
+            <a:off x="4434840" y="1737360"/>
+            <a:ext cx="73152" cy="1298448"/>
+          </a:xfrm>
+          <a:prstGeom prst="rect">
+            <a:avLst/>
+          </a:prstGeom>
+          <a:solidFill>
+            <a:srgbClr val="38BDF8"/>
+          </a:solidFill>
+          <a:ln>
+            <a:noFill/>
+          </a:ln>
+        </p:spPr>
+        <p:style>
+          <a:lnRef idx="1">
+            <a:schemeClr val="accent1"/>
+          </a:lnRef>
+          <a:fillRef idx="3">
+            <a:schemeClr val="accent1"/>
+          </a:fillRef>
+          <a:effectRef idx="2">
+            <a:schemeClr val="accent1"/>
+          </a:effectRef>
+          <a:fontRef idx="minor">
+            <a:schemeClr val="lt1"/>
+          </a:fontRef>
+        </p:style>
+        <p:txBody>
+          <a:bodyPr rtlCol="0" anchor="ctr"/>
+          <a:lstStyle/>
+          <a:p>
+            <a:pPr algn="ctr"/>
+          </a:p>
+        </p:txBody>
+      </p:sp>
+      <p:sp>
+        <p:nvSpPr>
+          <p:cNvPr id="12" name="TextBox 11"/>
+          <p:cNvSpPr txBox="1"/>
+          <p:nvPr/>
+        </p:nvSpPr>
+        <p:spPr>
+          <a:xfrm>
+            <a:off x="4663440" y="1883664"/>
+            <a:ext cx="2862072" cy="219456"/>
+          </a:xfrm>
+          <a:prstGeom prst="rect">
+            <a:avLst/>
+          </a:prstGeom>
+          <a:noFill/>
+        </p:spPr>
+        <p:txBody>
+          <a:bodyPr wrap="square" lIns="0" rIns="0" tIns="0" bIns="0" anchor="t">
+            <a:spAutoFit/>
+          </a:bodyPr>
+          <a:lstStyle/>
+          <a:p>
+            <a:pPr algn="l"/>
+            <a:r>
+              <a:rPr sz="1200" b="1">
+                <a:solidFill>
+                  <a:srgbClr val="38BDF8"/>
+                </a:solidFill>
+                <a:latin typeface="Aptos"/>
+              </a:rPr>
+              <a:t>Qué aprendimos</a:t>
+            </a:r>
+          </a:p>
+        </p:txBody>
+      </p:sp>
+      <p:sp>
+        <p:nvSpPr>
+          <p:cNvPr id="13" name="TextBox 12"/>
+          <p:cNvSpPr txBox="1"/>
+          <p:nvPr/>
+        </p:nvSpPr>
+        <p:spPr>
+          <a:xfrm>
+            <a:off x="4663440" y="2167128"/>
+            <a:ext cx="2862072" cy="786383"/>
+          </a:xfrm>
+          <a:prstGeom prst="rect">
+            <a:avLst/>
+          </a:prstGeom>
+          <a:noFill/>
+        </p:spPr>
+        <p:txBody>
+          <a:bodyPr wrap="square" lIns="0" rIns="0" tIns="0" bIns="0" anchor="t">
+            <a:spAutoFit/>
+          </a:bodyPr>
+          <a:lstStyle/>
+          <a:p>
+            <a:pPr algn="l"/>
+            <a:r>
+              <a:rPr sz="1100" b="0">
+                <a:solidFill>
+                  <a:srgbClr val="0A1820"/>
+                </a:solidFill>
+                <a:latin typeface="Aptos"/>
+              </a:rPr>
+              <a:t>Monitorear no es solo saber si un contenedor vive: también hay que medir servicio, backend, DB, SLO y rutas bajo presión.</a:t>
+            </a:r>
+          </a:p>
+        </p:txBody>
+      </p:sp>
+      <p:sp>
+        <p:nvSpPr>
+          <p:cNvPr id="14" name="Rounded Rectangle 13"/>
+          <p:cNvSpPr/>
+          <p:nvPr/>
+        </p:nvSpPr>
+        <p:spPr>
+          <a:xfrm>
+            <a:off x="8092440" y="1737360"/>
+            <a:ext cx="3246120" cy="1298448"/>
+          </a:xfrm>
+          <a:prstGeom prst="roundRect">
+            <a:avLst/>
+          </a:prstGeom>
+          <a:solidFill>
+            <a:srgbClr val="FFFFFF"/>
+          </a:solidFill>
+          <a:ln w="10160">
+            <a:solidFill>
+              <a:srgbClr val="BFCCD6"/>
+            </a:solidFill>
+          </a:ln>
+        </p:spPr>
+        <p:style>
+          <a:lnRef idx="1">
+            <a:schemeClr val="accent1"/>
+          </a:lnRef>
+          <a:fillRef idx="3">
+            <a:schemeClr val="accent1"/>
+          </a:fillRef>
+          <a:effectRef idx="2">
+            <a:schemeClr val="accent1"/>
+          </a:effectRef>
+          <a:fontRef idx="minor">
+            <a:schemeClr val="lt1"/>
+          </a:fontRef>
+        </p:style>
+        <p:txBody>
+          <a:bodyPr rtlCol="0" anchor="ctr"/>
+          <a:lstStyle/>
+          <a:p>
+            <a:pPr algn="ctr"/>
+          </a:p>
+        </p:txBody>
+      </p:sp>
+      <p:sp>
+        <p:nvSpPr>
+          <p:cNvPr id="15" name="Rectangle 14"/>
+          <p:cNvSpPr/>
+          <p:nvPr/>
+        </p:nvSpPr>
+        <p:spPr>
+          <a:xfrm>
+            <a:off x="8092440" y="1737360"/>
+            <a:ext cx="73152" cy="1298448"/>
+          </a:xfrm>
+          <a:prstGeom prst="rect">
+            <a:avLst/>
+          </a:prstGeom>
+          <a:solidFill>
+            <a:srgbClr val="F59E0B"/>
+          </a:solidFill>
+          <a:ln>
+            <a:noFill/>
+          </a:ln>
+        </p:spPr>
+        <p:style>
+          <a:lnRef idx="1">
+            <a:schemeClr val="accent1"/>
+          </a:lnRef>
+          <a:fillRef idx="3">
+            <a:schemeClr val="accent1"/>
+          </a:fillRef>
+          <a:effectRef idx="2">
+            <a:schemeClr val="accent1"/>
+          </a:effectRef>
+          <a:fontRef idx="minor">
+            <a:schemeClr val="lt1"/>
+          </a:fontRef>
+        </p:style>
+        <p:txBody>
+          <a:bodyPr rtlCol="0" anchor="ctr"/>
+          <a:lstStyle/>
+          <a:p>
+            <a:pPr algn="ctr"/>
+          </a:p>
+        </p:txBody>
+      </p:sp>
+      <p:sp>
+        <p:nvSpPr>
+          <p:cNvPr id="16" name="TextBox 15"/>
+          <p:cNvSpPr txBox="1"/>
+          <p:nvPr/>
+        </p:nvSpPr>
+        <p:spPr>
+          <a:xfrm>
+            <a:off x="8321040" y="1883664"/>
+            <a:ext cx="2862072" cy="219456"/>
+          </a:xfrm>
+          <a:prstGeom prst="rect">
+            <a:avLst/>
+          </a:prstGeom>
+          <a:noFill/>
+        </p:spPr>
+        <p:txBody>
+          <a:bodyPr wrap="square" lIns="0" rIns="0" tIns="0" bIns="0" anchor="t">
+            <a:spAutoFit/>
+          </a:bodyPr>
+          <a:lstStyle/>
+          <a:p>
+            <a:pPr algn="l"/>
+            <a:r>
+              <a:rPr sz="1200" b="1">
+                <a:solidFill>
+                  <a:srgbClr val="F59E0B"/>
+                </a:solidFill>
+                <a:latin typeface="Aptos"/>
+              </a:rPr>
+              <a:t>Limitación honesta</a:t>
+            </a:r>
+          </a:p>
+        </p:txBody>
+      </p:sp>
+      <p:sp>
+        <p:nvSpPr>
+          <p:cNvPr id="17" name="TextBox 16"/>
+          <p:cNvSpPr txBox="1"/>
+          <p:nvPr/>
+        </p:nvSpPr>
+        <p:spPr>
+          <a:xfrm>
+            <a:off x="8321040" y="2167128"/>
+            <a:ext cx="2862072" cy="786383"/>
+          </a:xfrm>
+          <a:prstGeom prst="rect">
+            <a:avLst/>
+          </a:prstGeom>
+          <a:noFill/>
+        </p:spPr>
+        <p:txBody>
+          <a:bodyPr wrap="square" lIns="0" rIns="0" tIns="0" bIns="0" anchor="t">
+            <a:spAutoFit/>
+          </a:bodyPr>
+          <a:lstStyle/>
+          <a:p>
+            <a:pPr algn="l"/>
+            <a:r>
+              <a:rPr sz="1100" b="0">
+                <a:solidFill>
+                  <a:srgbClr val="0A1820"/>
+                </a:solidFill>
+                <a:latin typeface="Aptos"/>
+              </a:rPr>
+              <a:t>El SLO del portal es de laboratorio y vive en memoria del proceso; Zabbix conserva el histórico real de eventos e items.</a:t>
+            </a:r>
+          </a:p>
+        </p:txBody>
+      </p:sp>
+      <p:sp>
+        <p:nvSpPr>
+          <p:cNvPr id="18" name="TextBox 17"/>
+          <p:cNvSpPr txBox="1"/>
+          <p:nvPr/>
+        </p:nvSpPr>
+        <p:spPr>
+          <a:xfrm>
+            <a:off x="822960" y="3822191"/>
+            <a:ext cx="1828800" cy="228600"/>
+          </a:xfrm>
+          <a:prstGeom prst="rect">
+            <a:avLst/>
+          </a:prstGeom>
+          <a:noFill/>
+        </p:spPr>
+        <p:txBody>
+          <a:bodyPr wrap="square" lIns="0" rIns="0" tIns="0" bIns="0" anchor="t">
+            <a:spAutoFit/>
+          </a:bodyPr>
+          <a:lstStyle/>
+          <a:p>
+            <a:pPr algn="l"/>
+            <a:r>
+              <a:rPr sz="1100" b="1">
+                <a:solidFill>
+                  <a:srgbClr val="5C6975"/>
+                </a:solidFill>
+                <a:latin typeface="Aptos"/>
+              </a:rPr>
+              <a:t>Conclusión</a:t>
+            </a:r>
+          </a:p>
+        </p:txBody>
+      </p:sp>
+      <p:sp>
+        <p:nvSpPr>
+          <p:cNvPr id="19" name="TextBox 18"/>
+          <p:cNvSpPr txBox="1"/>
+          <p:nvPr/>
+        </p:nvSpPr>
+        <p:spPr>
+          <a:xfrm>
+            <a:off x="822960" y="4224528"/>
+            <a:ext cx="9875520" cy="749808"/>
+          </a:xfrm>
+          <a:prstGeom prst="rect">
+            <a:avLst/>
+          </a:prstGeom>
+          <a:noFill/>
+        </p:spPr>
+        <p:txBody>
+          <a:bodyPr wrap="square" lIns="0" rIns="0" tIns="0" bIns="0" anchor="t">
+            <a:spAutoFit/>
+          </a:bodyPr>
+          <a:lstStyle/>
+          <a:p>
+            <a:pPr algn="l"/>
+            <a:r>
+              <a:rPr sz="2400" b="1">
+                <a:solidFill>
+                  <a:srgbClr val="0A1820"/>
+                </a:solidFill>
+                <a:latin typeface="Aptos"/>
+              </a:rPr>
+              <a:t>El proyecto cumple los requisitos base y los amplía con una aplicación real observable: frontend, backend, MariaDB, /metrics, SLO, analíticas, Artillery y matriz 13/13.</a:t>
+            </a:r>
+          </a:p>
+        </p:txBody>
+      </p:sp>
+      <p:cxnSp>
+        <p:nvCxnSpPr>
+          <p:cNvPr id="20" name="Connector 19"/>
+          <p:cNvCxnSpPr/>
+          <p:nvPr/>
+        </p:nvCxnSpPr>
+        <p:spPr>
+          <a:xfrm>
+            <a:off x="502920" y="6428232"/>
+            <a:ext cx="11155680" cy="0"/>
+          </a:xfrm>
+          <a:prstGeom prst="line">
+            <a:avLst/>
+          </a:prstGeom>
+          <a:ln w="8890">
+            <a:solidFill>
+              <a:srgbClr val="BFCCD6"/>
+            </a:solidFill>
+          </a:ln>
+        </p:spPr>
+        <p:style>
+          <a:lnRef idx="2">
+            <a:schemeClr val="accent1"/>
+          </a:lnRef>
+          <a:fillRef idx="0">
+            <a:schemeClr val="accent1"/>
+          </a:fillRef>
+          <a:effectRef idx="1">
+            <a:schemeClr val="accent1"/>
+          </a:effectRef>
+          <a:fontRef idx="minor">
+            <a:schemeClr val="tx1"/>
+          </a:fontRef>
+        </p:style>
+      </p:cxnSp>
+      <p:sp>
+        <p:nvSpPr>
+          <p:cNvPr id="21" name="TextBox 20"/>
+          <p:cNvSpPr txBox="1"/>
+          <p:nvPr/>
+        </p:nvSpPr>
+        <p:spPr>
+          <a:xfrm>
+            <a:off x="502920" y="6519672"/>
+            <a:ext cx="4754880" cy="164592"/>
+          </a:xfrm>
+          <a:prstGeom prst="rect">
+            <a:avLst/>
+          </a:prstGeom>
+          <a:noFill/>
+        </p:spPr>
+        <p:txBody>
+          <a:bodyPr wrap="square" lIns="0" rIns="0" tIns="0" bIns="0" anchor="t">
+            <a:spAutoFit/>
+          </a:bodyPr>
+          <a:lstStyle/>
+          <a:p>
+            <a:pPr algn="l"/>
+            <a:r>
+              <a:rPr sz="750" b="0">
+                <a:solidFill>
+                  <a:srgbClr val="5C6975"/>
+                </a:solidFill>
+                <a:latin typeface="Aptos"/>
+              </a:rPr>
+              <a:t>Proyecto 7 - Monitoreo de infraestructura con Zabbix</a:t>
+            </a:r>
+          </a:p>
+        </p:txBody>
+      </p:sp>
+      <p:sp>
+        <p:nvSpPr>
+          <p:cNvPr id="22" name="TextBox 21"/>
+          <p:cNvSpPr txBox="1"/>
+          <p:nvPr/>
+        </p:nvSpPr>
+        <p:spPr>
+          <a:xfrm>
+            <a:off x="10972800" y="6519672"/>
+            <a:ext cx="640080" cy="164592"/>
+          </a:xfrm>
+          <a:prstGeom prst="rect">
+            <a:avLst/>
+          </a:prstGeom>
+          <a:noFill/>
+        </p:spPr>
+        <p:txBody>
+          <a:bodyPr wrap="square" lIns="0" rIns="0" tIns="0" bIns="0" anchor="t">
+            <a:spAutoFit/>
+          </a:bodyPr>
+          <a:lstStyle/>
+          <a:p>
+            <a:pPr algn="r"/>
+            <a:r>
+              <a:rPr sz="750" b="0">
+                <a:solidFill>
+                  <a:srgbClr val="5C6975"/>
+                </a:solidFill>
+                <a:latin typeface="Aptos"/>
+              </a:rPr>
+              <a:t>16/17</a:t>
+            </a:r>
+          </a:p>
+        </p:txBody>
+      </p:sp>
+    </p:spTree>
+  </p:cSld>
+  <p:clrMapOvr>
+    <a:masterClrMapping/>
+  </p:clrMapOvr>
+</p:sld>
+</file>
+
+<file path=ppt/slides/slide17.xml><?xml version="1.0" encoding="utf-8"?>
+<p:sld xmlns:a="http://schemas.openxmlformats.org/drawingml/2006/main" xmlns:p="http://schemas.openxmlformats.org/presentationml/2006/main" xmlns:r="http://schemas.openxmlformats.org/officeDocument/2006/relationships">
+  <p:cSld>
+    <p:bg>
+      <p:bgPr>
+        <a:solidFill>
+          <a:srgbClr val="0A1820"/>
+        </a:solidFill>
+        <a:effectLst/>
+      </p:bgPr>
+    </p:bg>
+    <p:spTree>
+      <p:nvGrpSpPr>
+        <p:cNvPr id="1" name=""/>
+        <p:cNvGrpSpPr/>
+        <p:nvPr/>
+      </p:nvGrpSpPr>
+      <p:grpSpPr/>
+      <p:sp>
+        <p:nvSpPr>
+          <p:cNvPr id="2" name="TextBox 1"/>
+          <p:cNvSpPr txBox="1"/>
+          <p:nvPr/>
+        </p:nvSpPr>
+        <p:spPr>
+          <a:xfrm>
+            <a:off x="502920" y="384048"/>
+            <a:ext cx="384048" cy="201168"/>
+          </a:xfrm>
+          <a:prstGeom prst="rect">
+            <a:avLst/>
+          </a:prstGeom>
+          <a:noFill/>
+        </p:spPr>
+        <p:txBody>
+          <a:bodyPr wrap="square" lIns="0" rIns="0" tIns="0" bIns="0" anchor="t">
+            <a:spAutoFit/>
+          </a:bodyPr>
+          <a:lstStyle/>
+          <a:p>
+            <a:pPr algn="l"/>
+            <a:r>
+              <a:rPr sz="800" b="1">
+                <a:solidFill>
+                  <a:srgbClr val="22C5AA"/>
+                </a:solidFill>
+                <a:latin typeface="Aptos"/>
+              </a:rPr>
+              <a:t>17</a:t>
+            </a:r>
+          </a:p>
+        </p:txBody>
+      </p:sp>
+      <p:cxnSp>
+        <p:nvCxnSpPr>
+          <p:cNvPr id="3" name="Connector 2"/>
+          <p:cNvCxnSpPr/>
+          <p:nvPr/>
+        </p:nvCxnSpPr>
+        <p:spPr>
+          <a:xfrm>
+            <a:off x="941832" y="475488"/>
+            <a:ext cx="685800" cy="0"/>
+          </a:xfrm>
+          <a:prstGeom prst="line">
+            <a:avLst/>
+          </a:prstGeom>
+          <a:ln w="13970">
+            <a:solidFill>
+              <a:srgbClr val="22C5AA"/>
+            </a:solidFill>
+          </a:ln>
+        </p:spPr>
+        <p:style>
+          <a:lnRef idx="2">
+            <a:schemeClr val="accent1"/>
+          </a:lnRef>
+          <a:fillRef idx="0">
+            <a:schemeClr val="accent1"/>
+          </a:fillRef>
+          <a:effectRef idx="1">
+            <a:schemeClr val="accent1"/>
+          </a:effectRef>
+          <a:fontRef idx="minor">
+            <a:schemeClr val="tx1"/>
+          </a:fontRef>
+        </p:style>
+      </p:cxnSp>
+      <p:sp>
+        <p:nvSpPr>
+          <p:cNvPr id="4" name="TextBox 3"/>
+          <p:cNvSpPr txBox="1"/>
+          <p:nvPr/>
+        </p:nvSpPr>
+        <p:spPr>
+          <a:xfrm>
+            <a:off x="1737360" y="356616"/>
+            <a:ext cx="3108960" cy="274320"/>
+          </a:xfrm>
+          <a:prstGeom prst="rect">
+            <a:avLst/>
+          </a:prstGeom>
+          <a:noFill/>
+        </p:spPr>
+        <p:txBody>
+          <a:bodyPr wrap="square" lIns="0" rIns="0" tIns="0" bIns="0" anchor="t">
+            <a:spAutoFit/>
+          </a:bodyPr>
+          <a:lstStyle/>
+          <a:p>
+            <a:pPr algn="l"/>
+            <a:r>
+              <a:rPr sz="800" b="1">
+                <a:solidFill>
+                  <a:srgbClr val="22C5AA"/>
+                </a:solidFill>
+                <a:latin typeface="Aptos"/>
+              </a:rPr>
+              <a:t>REFERENCIAS</a:t>
+            </a:r>
+          </a:p>
+        </p:txBody>
+      </p:sp>
+      <p:sp>
+        <p:nvSpPr>
+          <p:cNvPr id="5" name="TextBox 4"/>
+          <p:cNvSpPr txBox="1"/>
+          <p:nvPr/>
+        </p:nvSpPr>
+        <p:spPr>
+          <a:xfrm>
+            <a:off x="502920" y="713232"/>
+            <a:ext cx="7498079" cy="868680"/>
+          </a:xfrm>
+          <a:prstGeom prst="rect">
+            <a:avLst/>
+          </a:prstGeom>
+          <a:noFill/>
+        </p:spPr>
+        <p:txBody>
+          <a:bodyPr wrap="square" lIns="0" rIns="0" tIns="0" bIns="0" anchor="t">
+            <a:spAutoFit/>
+          </a:bodyPr>
+          <a:lstStyle/>
+          <a:p>
+            <a:pPr algn="l"/>
+            <a:r>
+              <a:rPr sz="3000" b="1">
+                <a:solidFill>
+                  <a:srgbClr val="FFFFFF"/>
+                </a:solidFill>
+                <a:latin typeface="Aptos Display"/>
+              </a:rPr>
+              <a:t>Las decisiones se apoyan en documentación oficial y herramientas reproducibles.</a:t>
+            </a:r>
+          </a:p>
+        </p:txBody>
+      </p:sp>
+      <p:sp>
+        <p:nvSpPr>
+          <p:cNvPr id="6" name="Rounded Rectangle 5"/>
+          <p:cNvSpPr/>
+          <p:nvPr/>
+        </p:nvSpPr>
+        <p:spPr>
+          <a:xfrm>
+            <a:off x="822960" y="1691640"/>
+            <a:ext cx="4617720" cy="694944"/>
+          </a:xfrm>
+          <a:prstGeom prst="roundRect">
+            <a:avLst/>
+          </a:prstGeom>
+          <a:solidFill>
+            <a:srgbClr val="102833"/>
+          </a:solidFill>
+          <a:ln w="10160">
+            <a:solidFill>
+              <a:srgbClr val="304954"/>
+            </a:solidFill>
+          </a:ln>
+        </p:spPr>
+        <p:style>
+          <a:lnRef idx="1">
+            <a:schemeClr val="accent1"/>
+          </a:lnRef>
+          <a:fillRef idx="3">
+            <a:schemeClr val="accent1"/>
+          </a:fillRef>
+          <a:effectRef idx="2">
+            <a:schemeClr val="accent1"/>
+          </a:effectRef>
+          <a:fontRef idx="minor">
+            <a:schemeClr val="lt1"/>
+          </a:fontRef>
+        </p:style>
+        <p:txBody>
+          <a:bodyPr rtlCol="0" anchor="ctr"/>
+          <a:lstStyle/>
+          <a:p>
+            <a:pPr algn="ctr"/>
+          </a:p>
+        </p:txBody>
+      </p:sp>
+      <p:sp>
+        <p:nvSpPr>
+          <p:cNvPr id="7" name="TextBox 6"/>
+          <p:cNvSpPr txBox="1"/>
+          <p:nvPr/>
+        </p:nvSpPr>
+        <p:spPr>
+          <a:xfrm>
+            <a:off x="1005840" y="1819656"/>
+            <a:ext cx="2834640" cy="201168"/>
+          </a:xfrm>
+          <a:prstGeom prst="rect">
+            <a:avLst/>
+          </a:prstGeom>
+          <a:noFill/>
+        </p:spPr>
+        <p:txBody>
+          <a:bodyPr wrap="square" lIns="0" rIns="0" tIns="0" bIns="0" anchor="t">
+            <a:spAutoFit/>
+          </a:bodyPr>
+          <a:lstStyle/>
+          <a:p>
+            <a:pPr algn="l"/>
+            <a:r>
+              <a:rPr sz="1150" b="1">
+                <a:solidFill>
+                  <a:srgbClr val="22C5AA"/>
+                </a:solidFill>
+                <a:latin typeface="Aptos"/>
+              </a:rPr>
+              <a:t>Zabbix Documentation 6.0</a:t>
+            </a:r>
+          </a:p>
+        </p:txBody>
+      </p:sp>
+      <p:sp>
+        <p:nvSpPr>
+          <p:cNvPr id="8" name="TextBox 7"/>
+          <p:cNvSpPr txBox="1"/>
+          <p:nvPr/>
+        </p:nvSpPr>
+        <p:spPr>
+          <a:xfrm>
+            <a:off x="1005840" y="2084832"/>
+            <a:ext cx="4160520" cy="164592"/>
+          </a:xfrm>
+          <a:prstGeom prst="rect">
+            <a:avLst/>
+          </a:prstGeom>
+          <a:noFill/>
+        </p:spPr>
+        <p:txBody>
+          <a:bodyPr wrap="square" lIns="0" rIns="0" tIns="0" bIns="0" anchor="t">
+            <a:spAutoFit/>
+          </a:bodyPr>
+          <a:lstStyle/>
+          <a:p>
+            <a:pPr algn="l"/>
+            <a:r>
+              <a:rPr sz="850" b="0">
+                <a:solidFill>
+                  <a:srgbClr val="CAD5DB"/>
+                </a:solidFill>
+                <a:latin typeface="Aptos"/>
+              </a:rPr>
+              <a:t>zabbix.com/documentation/6.0</a:t>
+            </a:r>
+          </a:p>
+        </p:txBody>
+      </p:sp>
+      <p:sp>
+        <p:nvSpPr>
+          <p:cNvPr id="9" name="Rounded Rectangle 8"/>
+          <p:cNvSpPr/>
+          <p:nvPr/>
+        </p:nvSpPr>
+        <p:spPr>
+          <a:xfrm>
+            <a:off x="6080760" y="1691640"/>
+            <a:ext cx="4617720" cy="694944"/>
+          </a:xfrm>
+          <a:prstGeom prst="roundRect">
+            <a:avLst/>
+          </a:prstGeom>
+          <a:solidFill>
+            <a:srgbClr val="102833"/>
+          </a:solidFill>
+          <a:ln w="10160">
+            <a:solidFill>
+              <a:srgbClr val="304954"/>
+            </a:solidFill>
+          </a:ln>
+        </p:spPr>
+        <p:style>
+          <a:lnRef idx="1">
+            <a:schemeClr val="accent1"/>
+          </a:lnRef>
+          <a:fillRef idx="3">
+            <a:schemeClr val="accent1"/>
+          </a:fillRef>
+          <a:effectRef idx="2">
+            <a:schemeClr val="accent1"/>
+          </a:effectRef>
+          <a:fontRef idx="minor">
+            <a:schemeClr val="lt1"/>
+          </a:fontRef>
+        </p:style>
+        <p:txBody>
+          <a:bodyPr rtlCol="0" anchor="ctr"/>
+          <a:lstStyle/>
+          <a:p>
+            <a:pPr algn="ctr"/>
+          </a:p>
+        </p:txBody>
+      </p:sp>
+      <p:sp>
+        <p:nvSpPr>
+          <p:cNvPr id="10" name="TextBox 9"/>
+          <p:cNvSpPr txBox="1"/>
+          <p:nvPr/>
+        </p:nvSpPr>
+        <p:spPr>
+          <a:xfrm>
+            <a:off x="6263640" y="1819656"/>
+            <a:ext cx="2834640" cy="201168"/>
+          </a:xfrm>
+          <a:prstGeom prst="rect">
+            <a:avLst/>
+          </a:prstGeom>
+          <a:noFill/>
+        </p:spPr>
+        <p:txBody>
+          <a:bodyPr wrap="square" lIns="0" rIns="0" tIns="0" bIns="0" anchor="t">
+            <a:spAutoFit/>
+          </a:bodyPr>
+          <a:lstStyle/>
+          <a:p>
+            <a:pPr algn="l"/>
+            <a:r>
+              <a:rPr sz="1150" b="1">
+                <a:solidFill>
+                  <a:srgbClr val="38BDF8"/>
+                </a:solidFill>
+                <a:latin typeface="Aptos"/>
+              </a:rPr>
+              <a:t>Docker Compose</a:t>
+            </a:r>
+          </a:p>
+        </p:txBody>
+      </p:sp>
+      <p:sp>
+        <p:nvSpPr>
+          <p:cNvPr id="11" name="TextBox 10"/>
+          <p:cNvSpPr txBox="1"/>
+          <p:nvPr/>
+        </p:nvSpPr>
+        <p:spPr>
+          <a:xfrm>
+            <a:off x="6263640" y="2084832"/>
+            <a:ext cx="4160520" cy="164592"/>
+          </a:xfrm>
+          <a:prstGeom prst="rect">
+            <a:avLst/>
+          </a:prstGeom>
+          <a:noFill/>
+        </p:spPr>
+        <p:txBody>
+          <a:bodyPr wrap="square" lIns="0" rIns="0" tIns="0" bIns="0" anchor="t">
+            <a:spAutoFit/>
+          </a:bodyPr>
+          <a:lstStyle/>
+          <a:p>
+            <a:pPr algn="l"/>
+            <a:r>
+              <a:rPr sz="850" b="0">
+                <a:solidFill>
+                  <a:srgbClr val="CAD5DB"/>
+                </a:solidFill>
+                <a:latin typeface="Aptos"/>
+              </a:rPr>
+              <a:t>docs.docker.com/compose</a:t>
+            </a:r>
+          </a:p>
+        </p:txBody>
+      </p:sp>
+      <p:sp>
+        <p:nvSpPr>
+          <p:cNvPr id="12" name="Rounded Rectangle 11"/>
+          <p:cNvSpPr/>
+          <p:nvPr/>
+        </p:nvSpPr>
+        <p:spPr>
+          <a:xfrm>
+            <a:off x="822960" y="2770632"/>
+            <a:ext cx="4617720" cy="694944"/>
+          </a:xfrm>
+          <a:prstGeom prst="roundRect">
+            <a:avLst/>
+          </a:prstGeom>
+          <a:solidFill>
+            <a:srgbClr val="102833"/>
+          </a:solidFill>
+          <a:ln w="10160">
+            <a:solidFill>
+              <a:srgbClr val="304954"/>
+            </a:solidFill>
+          </a:ln>
+        </p:spPr>
+        <p:style>
+          <a:lnRef idx="1">
+            <a:schemeClr val="accent1"/>
+          </a:lnRef>
+          <a:fillRef idx="3">
+            <a:schemeClr val="accent1"/>
+          </a:fillRef>
+          <a:effectRef idx="2">
+            <a:schemeClr val="accent1"/>
+          </a:effectRef>
+          <a:fontRef idx="minor">
+            <a:schemeClr val="lt1"/>
+          </a:fontRef>
+        </p:style>
+        <p:txBody>
+          <a:bodyPr rtlCol="0" anchor="ctr"/>
+          <a:lstStyle/>
+          <a:p>
+            <a:pPr algn="ctr"/>
+          </a:p>
+        </p:txBody>
+      </p:sp>
+      <p:sp>
+        <p:nvSpPr>
+          <p:cNvPr id="13" name="TextBox 12"/>
+          <p:cNvSpPr txBox="1"/>
+          <p:nvPr/>
+        </p:nvSpPr>
+        <p:spPr>
+          <a:xfrm>
+            <a:off x="1005840" y="2898648"/>
+            <a:ext cx="2834640" cy="201168"/>
+          </a:xfrm>
+          <a:prstGeom prst="rect">
+            <a:avLst/>
+          </a:prstGeom>
+          <a:noFill/>
+        </p:spPr>
+        <p:txBody>
+          <a:bodyPr wrap="square" lIns="0" rIns="0" tIns="0" bIns="0" anchor="t">
+            <a:spAutoFit/>
+          </a:bodyPr>
+          <a:lstStyle/>
+          <a:p>
+            <a:pPr algn="l"/>
+            <a:r>
+              <a:rPr sz="1150" b="1">
+                <a:solidFill>
+                  <a:srgbClr val="F59E0B"/>
+                </a:solidFill>
+                <a:latin typeface="Aptos"/>
+              </a:rPr>
+              <a:t>MailHog</a:t>
+            </a:r>
+          </a:p>
+        </p:txBody>
+      </p:sp>
+      <p:sp>
+        <p:nvSpPr>
+          <p:cNvPr id="14" name="TextBox 13"/>
+          <p:cNvSpPr txBox="1"/>
+          <p:nvPr/>
+        </p:nvSpPr>
+        <p:spPr>
+          <a:xfrm>
+            <a:off x="1005840" y="3163824"/>
+            <a:ext cx="4160520" cy="164592"/>
+          </a:xfrm>
+          <a:prstGeom prst="rect">
+            <a:avLst/>
+          </a:prstGeom>
+          <a:noFill/>
+        </p:spPr>
+        <p:txBody>
+          <a:bodyPr wrap="square" lIns="0" rIns="0" tIns="0" bIns="0" anchor="t">
+            <a:spAutoFit/>
+          </a:bodyPr>
+          <a:lstStyle/>
+          <a:p>
+            <a:pPr algn="l"/>
+            <a:r>
+              <a:rPr sz="850" b="0">
+                <a:solidFill>
+                  <a:srgbClr val="CAD5DB"/>
+                </a:solidFill>
+                <a:latin typeface="Aptos"/>
+              </a:rPr>
+              <a:t>github.com/mailhog/MailHog</a:t>
+            </a:r>
+          </a:p>
+        </p:txBody>
+      </p:sp>
+      <p:sp>
+        <p:nvSpPr>
+          <p:cNvPr id="15" name="Rounded Rectangle 14"/>
+          <p:cNvSpPr/>
+          <p:nvPr/>
+        </p:nvSpPr>
+        <p:spPr>
+          <a:xfrm>
+            <a:off x="6080760" y="2770632"/>
+            <a:ext cx="4617720" cy="694944"/>
+          </a:xfrm>
+          <a:prstGeom prst="roundRect">
+            <a:avLst/>
+          </a:prstGeom>
+          <a:solidFill>
+            <a:srgbClr val="102833"/>
+          </a:solidFill>
+          <a:ln w="10160">
+            <a:solidFill>
+              <a:srgbClr val="304954"/>
+            </a:solidFill>
+          </a:ln>
+        </p:spPr>
+        <p:style>
+          <a:lnRef idx="1">
+            <a:schemeClr val="accent1"/>
+          </a:lnRef>
+          <a:fillRef idx="3">
+            <a:schemeClr val="accent1"/>
+          </a:fillRef>
+          <a:effectRef idx="2">
+            <a:schemeClr val="accent1"/>
+          </a:effectRef>
+          <a:fontRef idx="minor">
+            <a:schemeClr val="lt1"/>
+          </a:fontRef>
+        </p:style>
+        <p:txBody>
+          <a:bodyPr rtlCol="0" anchor="ctr"/>
+          <a:lstStyle/>
+          <a:p>
+            <a:pPr algn="ctr"/>
+          </a:p>
+        </p:txBody>
+      </p:sp>
+      <p:sp>
+        <p:nvSpPr>
+          <p:cNvPr id="16" name="TextBox 15"/>
+          <p:cNvSpPr txBox="1"/>
+          <p:nvPr/>
+        </p:nvSpPr>
+        <p:spPr>
+          <a:xfrm>
+            <a:off x="6263640" y="2898648"/>
+            <a:ext cx="2834640" cy="201168"/>
+          </a:xfrm>
+          <a:prstGeom prst="rect">
+            <a:avLst/>
+          </a:prstGeom>
+          <a:noFill/>
+        </p:spPr>
+        <p:txBody>
+          <a:bodyPr wrap="square" lIns="0" rIns="0" tIns="0" bIns="0" anchor="t">
+            <a:spAutoFit/>
+          </a:bodyPr>
+          <a:lstStyle/>
+          <a:p>
+            <a:pPr algn="l"/>
+            <a:r>
+              <a:rPr sz="1150" b="1">
+                <a:solidFill>
+                  <a:srgbClr val="A3E635"/>
+                </a:solidFill>
+                <a:latin typeface="Aptos"/>
+              </a:rPr>
+              <a:t>Artillery Docs</a:t>
+            </a:r>
+          </a:p>
+        </p:txBody>
+      </p:sp>
+      <p:sp>
+        <p:nvSpPr>
+          <p:cNvPr id="17" name="TextBox 16"/>
+          <p:cNvSpPr txBox="1"/>
+          <p:nvPr/>
+        </p:nvSpPr>
+        <p:spPr>
+          <a:xfrm>
+            <a:off x="6263640" y="3163824"/>
+            <a:ext cx="4160520" cy="164592"/>
+          </a:xfrm>
+          <a:prstGeom prst="rect">
+            <a:avLst/>
+          </a:prstGeom>
+          <a:noFill/>
+        </p:spPr>
+        <p:txBody>
+          <a:bodyPr wrap="square" lIns="0" rIns="0" tIns="0" bIns="0" anchor="t">
+            <a:spAutoFit/>
+          </a:bodyPr>
+          <a:lstStyle/>
+          <a:p>
+            <a:pPr algn="l"/>
+            <a:r>
+              <a:rPr sz="850" b="0">
+                <a:solidFill>
+                  <a:srgbClr val="CAD5DB"/>
+                </a:solidFill>
+                <a:latin typeface="Aptos"/>
+              </a:rPr>
+              <a:t>artillery.io/docs</a:t>
+            </a:r>
+          </a:p>
+        </p:txBody>
+      </p:sp>
+      <p:sp>
+        <p:nvSpPr>
+          <p:cNvPr id="18" name="Rounded Rectangle 17"/>
+          <p:cNvSpPr/>
+          <p:nvPr/>
+        </p:nvSpPr>
+        <p:spPr>
+          <a:xfrm>
+            <a:off x="822960" y="3849624"/>
+            <a:ext cx="4617720" cy="694944"/>
+          </a:xfrm>
+          <a:prstGeom prst="roundRect">
+            <a:avLst/>
+          </a:prstGeom>
+          <a:solidFill>
+            <a:srgbClr val="102833"/>
+          </a:solidFill>
+          <a:ln w="10160">
+            <a:solidFill>
+              <a:srgbClr val="304954"/>
+            </a:solidFill>
+          </a:ln>
+        </p:spPr>
+        <p:style>
+          <a:lnRef idx="1">
+            <a:schemeClr val="accent1"/>
+          </a:lnRef>
+          <a:fillRef idx="3">
+            <a:schemeClr val="accent1"/>
+          </a:fillRef>
+          <a:effectRef idx="2">
+            <a:schemeClr val="accent1"/>
+          </a:effectRef>
+          <a:fontRef idx="minor">
+            <a:schemeClr val="lt1"/>
+          </a:fontRef>
+        </p:style>
+        <p:txBody>
+          <a:bodyPr rtlCol="0" anchor="ctr"/>
+          <a:lstStyle/>
+          <a:p>
+            <a:pPr algn="ctr"/>
+          </a:p>
+        </p:txBody>
+      </p:sp>
+      <p:sp>
+        <p:nvSpPr>
+          <p:cNvPr id="19" name="TextBox 18"/>
+          <p:cNvSpPr txBox="1"/>
+          <p:nvPr/>
+        </p:nvSpPr>
+        <p:spPr>
+          <a:xfrm>
+            <a:off x="1005840" y="3977639"/>
+            <a:ext cx="2834640" cy="201168"/>
+          </a:xfrm>
+          <a:prstGeom prst="rect">
+            <a:avLst/>
+          </a:prstGeom>
+          <a:noFill/>
+        </p:spPr>
+        <p:txBody>
+          <a:bodyPr wrap="square" lIns="0" rIns="0" tIns="0" bIns="0" anchor="t">
+            <a:spAutoFit/>
+          </a:bodyPr>
+          <a:lstStyle/>
+          <a:p>
+            <a:pPr algn="l"/>
+            <a:r>
+              <a:rPr sz="1150" b="1">
+                <a:solidFill>
+                  <a:srgbClr val="38BDF8"/>
+                </a:solidFill>
+                <a:latin typeface="Aptos"/>
+              </a:rPr>
+              <a:t>PostgreSQL / MariaDB</a:t>
+            </a:r>
+          </a:p>
+        </p:txBody>
+      </p:sp>
+      <p:sp>
+        <p:nvSpPr>
+          <p:cNvPr id="20" name="TextBox 19"/>
+          <p:cNvSpPr txBox="1"/>
+          <p:nvPr/>
+        </p:nvSpPr>
+        <p:spPr>
+          <a:xfrm>
+            <a:off x="1005840" y="4242816"/>
+            <a:ext cx="4160520" cy="164592"/>
+          </a:xfrm>
+          <a:prstGeom prst="rect">
+            <a:avLst/>
+          </a:prstGeom>
+          <a:noFill/>
+        </p:spPr>
+        <p:txBody>
+          <a:bodyPr wrap="square" lIns="0" rIns="0" tIns="0" bIns="0" anchor="t">
+            <a:spAutoFit/>
+          </a:bodyPr>
+          <a:lstStyle/>
+          <a:p>
+            <a:pPr algn="l"/>
+            <a:r>
+              <a:rPr sz="850" b="0">
+                <a:solidFill>
+                  <a:srgbClr val="CAD5DB"/>
+                </a:solidFill>
+                <a:latin typeface="Aptos"/>
+              </a:rPr>
+              <a:t>postgresql.org/docs + mariadb.org/documentation</a:t>
+            </a:r>
+          </a:p>
+        </p:txBody>
+      </p:sp>
+      <p:sp>
+        <p:nvSpPr>
+          <p:cNvPr id="21" name="Rounded Rectangle 20"/>
+          <p:cNvSpPr/>
+          <p:nvPr/>
+        </p:nvSpPr>
+        <p:spPr>
+          <a:xfrm>
+            <a:off x="6080760" y="3849624"/>
+            <a:ext cx="4617720" cy="694944"/>
+          </a:xfrm>
+          <a:prstGeom prst="roundRect">
+            <a:avLst/>
+          </a:prstGeom>
+          <a:solidFill>
+            <a:srgbClr val="102833"/>
+          </a:solidFill>
+          <a:ln w="10160">
+            <a:solidFill>
+              <a:srgbClr val="304954"/>
+            </a:solidFill>
+          </a:ln>
+        </p:spPr>
+        <p:style>
+          <a:lnRef idx="1">
+            <a:schemeClr val="accent1"/>
+          </a:lnRef>
+          <a:fillRef idx="3">
+            <a:schemeClr val="accent1"/>
+          </a:fillRef>
+          <a:effectRef idx="2">
+            <a:schemeClr val="accent1"/>
+          </a:effectRef>
+          <a:fontRef idx="minor">
+            <a:schemeClr val="lt1"/>
+          </a:fontRef>
+        </p:style>
+        <p:txBody>
+          <a:bodyPr rtlCol="0" anchor="ctr"/>
+          <a:lstStyle/>
+          <a:p>
+            <a:pPr algn="ctr"/>
+          </a:p>
+        </p:txBody>
+      </p:sp>
+      <p:sp>
+        <p:nvSpPr>
+          <p:cNvPr id="22" name="TextBox 21"/>
+          <p:cNvSpPr txBox="1"/>
+          <p:nvPr/>
+        </p:nvSpPr>
+        <p:spPr>
+          <a:xfrm>
+            <a:off x="6263640" y="3977639"/>
+            <a:ext cx="2834640" cy="201168"/>
+          </a:xfrm>
+          <a:prstGeom prst="rect">
+            <a:avLst/>
+          </a:prstGeom>
+          <a:noFill/>
+        </p:spPr>
+        <p:txBody>
+          <a:bodyPr wrap="square" lIns="0" rIns="0" tIns="0" bIns="0" anchor="t">
+            <a:spAutoFit/>
+          </a:bodyPr>
+          <a:lstStyle/>
+          <a:p>
+            <a:pPr algn="l"/>
+            <a:r>
+              <a:rPr sz="1150" b="1">
+                <a:solidFill>
+                  <a:srgbClr val="22C5AA"/>
+                </a:solidFill>
+                <a:latin typeface="Aptos"/>
+              </a:rPr>
+              <a:t>Caddy Automatic HTTPS</a:t>
+            </a:r>
+          </a:p>
+        </p:txBody>
+      </p:sp>
+      <p:sp>
+        <p:nvSpPr>
+          <p:cNvPr id="23" name="TextBox 22"/>
+          <p:cNvSpPr txBox="1"/>
+          <p:nvPr/>
+        </p:nvSpPr>
+        <p:spPr>
+          <a:xfrm>
+            <a:off x="6263640" y="4242816"/>
+            <a:ext cx="4160520" cy="164592"/>
+          </a:xfrm>
+          <a:prstGeom prst="rect">
+            <a:avLst/>
+          </a:prstGeom>
+          <a:noFill/>
+        </p:spPr>
+        <p:txBody>
+          <a:bodyPr wrap="square" lIns="0" rIns="0" tIns="0" bIns="0" anchor="t">
+            <a:spAutoFit/>
+          </a:bodyPr>
+          <a:lstStyle/>
+          <a:p>
+            <a:pPr algn="l"/>
+            <a:r>
+              <a:rPr sz="850" b="0">
+                <a:solidFill>
+                  <a:srgbClr val="CAD5DB"/>
+                </a:solidFill>
+                <a:latin typeface="Aptos"/>
+              </a:rPr>
+              <a:t>caddyserver.com/docs/automatic-https</a:t>
+            </a:r>
+          </a:p>
+        </p:txBody>
+      </p:sp>
+      <p:sp>
+        <p:nvSpPr>
+          <p:cNvPr id="24" name="TextBox 23"/>
+          <p:cNvSpPr txBox="1"/>
+          <p:nvPr/>
+        </p:nvSpPr>
+        <p:spPr>
+          <a:xfrm>
+            <a:off x="868680" y="5321808"/>
+            <a:ext cx="9966960" cy="457200"/>
+          </a:xfrm>
+          <a:prstGeom prst="rect">
+            <a:avLst/>
+          </a:prstGeom>
+          <a:noFill/>
+        </p:spPr>
+        <p:txBody>
+          <a:bodyPr wrap="square" lIns="0" rIns="0" tIns="0" bIns="0" anchor="t">
+            <a:spAutoFit/>
+          </a:bodyPr>
+          <a:lstStyle/>
+          <a:p>
+            <a:pPr algn="l"/>
+            <a:r>
+              <a:rPr sz="1700" b="1">
+                <a:solidFill>
+                  <a:srgbClr val="FFFFFF"/>
+                </a:solidFill>
+                <a:latin typeface="Aptos"/>
+              </a:rPr>
+              <a:t>Entregables: informe IEEE, presentación, repositorio GitHub, README, scripts de aprovisionamiento, Docker Compose, evidencias y demo pública HTTPS.</a:t>
+            </a:r>
+          </a:p>
+        </p:txBody>
+      </p:sp>
+      <p:cxnSp>
+        <p:nvCxnSpPr>
+          <p:cNvPr id="25" name="Connector 24"/>
+          <p:cNvCxnSpPr/>
+          <p:nvPr/>
+        </p:nvCxnSpPr>
+        <p:spPr>
+          <a:xfrm>
+            <a:off x="502920" y="6428232"/>
+            <a:ext cx="11155680" cy="0"/>
+          </a:xfrm>
+          <a:prstGeom prst="line">
+            <a:avLst/>
+          </a:prstGeom>
+          <a:ln w="8890">
+            <a:solidFill>
+              <a:srgbClr val="2A424D"/>
+            </a:solidFill>
+          </a:ln>
+        </p:spPr>
+        <p:style>
+          <a:lnRef idx="2">
+            <a:schemeClr val="accent1"/>
+          </a:lnRef>
+          <a:fillRef idx="0">
+            <a:schemeClr val="accent1"/>
+          </a:fillRef>
+          <a:effectRef idx="1">
+            <a:schemeClr val="accent1"/>
+          </a:effectRef>
+          <a:fontRef idx="minor">
+            <a:schemeClr val="tx1"/>
+          </a:fontRef>
+        </p:style>
+      </p:cxnSp>
+      <p:sp>
+        <p:nvSpPr>
+          <p:cNvPr id="26" name="TextBox 25"/>
+          <p:cNvSpPr txBox="1"/>
+          <p:nvPr/>
+        </p:nvSpPr>
+        <p:spPr>
+          <a:xfrm>
+            <a:off x="502920" y="6519672"/>
+            <a:ext cx="4754880" cy="164592"/>
+          </a:xfrm>
+          <a:prstGeom prst="rect">
+            <a:avLst/>
+          </a:prstGeom>
+          <a:noFill/>
+        </p:spPr>
+        <p:txBody>
+          <a:bodyPr wrap="square" lIns="0" rIns="0" tIns="0" bIns="0" anchor="t">
+            <a:spAutoFit/>
+          </a:bodyPr>
+          <a:lstStyle/>
+          <a:p>
+            <a:pPr algn="l"/>
+            <a:r>
+              <a:rPr sz="750" b="0">
+                <a:solidFill>
+                  <a:srgbClr val="8E9FAA"/>
+                </a:solidFill>
+                <a:latin typeface="Aptos"/>
+              </a:rPr>
+              <a:t>Proyecto 7 - Monitoreo de infraestructura con Zabbix</a:t>
+            </a:r>
+          </a:p>
+        </p:txBody>
+      </p:sp>
+      <p:sp>
+        <p:nvSpPr>
+          <p:cNvPr id="27" name="TextBox 26"/>
+          <p:cNvSpPr txBox="1"/>
+          <p:nvPr/>
+        </p:nvSpPr>
+        <p:spPr>
+          <a:xfrm>
+            <a:off x="10972800" y="6519672"/>
+            <a:ext cx="640080" cy="164592"/>
+          </a:xfrm>
+          <a:prstGeom prst="rect">
+            <a:avLst/>
+          </a:prstGeom>
+          <a:noFill/>
+        </p:spPr>
+        <p:txBody>
+          <a:bodyPr wrap="square" lIns="0" rIns="0" tIns="0" bIns="0" anchor="t">
+            <a:spAutoFit/>
+          </a:bodyPr>
+          <a:lstStyle/>
+          <a:p>
+            <a:pPr algn="r"/>
+            <a:r>
+              <a:rPr sz="750" b="0">
+                <a:solidFill>
+                  <a:srgbClr val="8E9FAA"/>
+                </a:solidFill>
+                <a:latin typeface="Aptos"/>
+              </a:rPr>
+              <a:t>17/17</a:t>
             </a:r>
           </a:p>
         </p:txBody>
@@ -9927,7 +13130,7 @@
                 </a:solidFill>
                 <a:latin typeface="Aptos"/>
               </a:rPr>
-              <a:t>02/14</a:t>
+              <a:t>02/17</a:t>
             </a:r>
           </a:p>
         </p:txBody>
@@ -10742,7 +13945,7 @@
                 </a:solidFill>
                 <a:latin typeface="Aptos"/>
               </a:rPr>
-              <a:t>03/14</a:t>
+              <a:t>03/17</a:t>
             </a:r>
           </a:p>
         </p:txBody>
@@ -12953,7 +16156,7 @@
                 </a:solidFill>
                 <a:latin typeface="Aptos"/>
               </a:rPr>
-              <a:t>04/14</a:t>
+              <a:t>04/17</a:t>
             </a:r>
           </a:p>
         </p:txBody>
@@ -14920,7 +18123,7 @@
                 </a:solidFill>
                 <a:latin typeface="Aptos"/>
               </a:rPr>
-              <a:t>05/14</a:t>
+              <a:t>05/17</a:t>
             </a:r>
           </a:p>
         </p:txBody>
@@ -16629,7 +19832,7 @@
                 </a:solidFill>
                 <a:latin typeface="Aptos"/>
               </a:rPr>
-              <a:t>06/14</a:t>
+              <a:t>06/17</a:t>
             </a:r>
           </a:p>
         </p:txBody>
@@ -17429,7 +20632,7 @@
                 </a:solidFill>
                 <a:latin typeface="Aptos"/>
               </a:rPr>
-              <a:t>07/14</a:t>
+              <a:t>07/17</a:t>
             </a:r>
           </a:p>
         </p:txBody>
@@ -18243,7 +21446,7 @@
                 </a:solidFill>
                 <a:latin typeface="Aptos"/>
               </a:rPr>
-              <a:t>08/14</a:t>
+              <a:t>08/17</a:t>
             </a:r>
           </a:p>
         </p:txBody>
@@ -19175,7 +22378,7 @@
                 </a:solidFill>
                 <a:latin typeface="Aptos"/>
               </a:rPr>
-              <a:t>09/14</a:t>
+              <a:t>09/17</a:t>
             </a:r>
           </a:p>
         </p:txBody>

</xml_diff>